<commit_message>
Put the actual team and neutral AI path on the cover
Replace the provider-specific cover label with AI API explanation path and identify Team Hulk Hogan with the supplied university and member names.

Constraint: Preserve the existing 10-slide design and editable evidence objects

Confidence: high

Scope-risk: narrow

Tested: PPTX finalizer, full-size cover render, PDF page render, 10-page count, package integrity

Not-tested: PowerPoint desktop
</commit_message>
<xml_diff>
--- a/slides/ChainLens-BLOCK-AI26-Proposal.pptx
+++ b/slides/ChainLens-BLOCK-AI26-Proposal.pptx
@@ -2,22 +2,22 @@
 <file path=ppt/presentation.xml><?xml version="1.0" encoding="utf-8"?>
 <p:presentation xmlns:p="http://schemas.openxmlformats.org/presentationml/2006/main">
   <p:sldMasterIdLst>
-    <p:sldMasterId xmlns:r="http://schemas.openxmlformats.org/officeDocument/2006/relationships" id="2147483648" r:id="R4852bcfea0f5438a"/>
+    <p:sldMasterId xmlns:r="http://schemas.openxmlformats.org/officeDocument/2006/relationships" id="2147483648" r:id="R3d0f792305a84604"/>
   </p:sldMasterIdLst>
   <p:notesMasterIdLst>
-    <p:notesMasterId xmlns:r="http://schemas.openxmlformats.org/officeDocument/2006/relationships" r:id="Rd0a79a75b051492e"/>
+    <p:notesMasterId xmlns:r="http://schemas.openxmlformats.org/officeDocument/2006/relationships" r:id="R66dc3f46c0004fc5"/>
   </p:notesMasterIdLst>
   <p:sldIdLst>
-    <p:sldId xmlns:r="http://schemas.openxmlformats.org/officeDocument/2006/relationships" id="256" r:id="Ra8dfc14401b74f60"/>
-    <p:sldId xmlns:r="http://schemas.openxmlformats.org/officeDocument/2006/relationships" id="257" r:id="R4aaec17adbda4342"/>
-    <p:sldId xmlns:r="http://schemas.openxmlformats.org/officeDocument/2006/relationships" id="258" r:id="R5a1429863acc4f21"/>
-    <p:sldId xmlns:r="http://schemas.openxmlformats.org/officeDocument/2006/relationships" id="259" r:id="R55d44952a32a4b9e"/>
-    <p:sldId xmlns:r="http://schemas.openxmlformats.org/officeDocument/2006/relationships" id="260" r:id="R57908d03d7c64933"/>
-    <p:sldId xmlns:r="http://schemas.openxmlformats.org/officeDocument/2006/relationships" id="261" r:id="R140db4e39d914f69"/>
-    <p:sldId xmlns:r="http://schemas.openxmlformats.org/officeDocument/2006/relationships" id="262" r:id="R524766d6964644cf"/>
-    <p:sldId xmlns:r="http://schemas.openxmlformats.org/officeDocument/2006/relationships" id="263" r:id="Re8f51293a4604cab"/>
-    <p:sldId xmlns:r="http://schemas.openxmlformats.org/officeDocument/2006/relationships" id="264" r:id="R467c19f22fd44ff5"/>
-    <p:sldId xmlns:r="http://schemas.openxmlformats.org/officeDocument/2006/relationships" id="265" r:id="R70ff161404954e91"/>
+    <p:sldId xmlns:r="http://schemas.openxmlformats.org/officeDocument/2006/relationships" id="256" r:id="R92b67e13bebd40f0"/>
+    <p:sldId xmlns:r="http://schemas.openxmlformats.org/officeDocument/2006/relationships" id="257" r:id="R7ff52a8082444207"/>
+    <p:sldId xmlns:r="http://schemas.openxmlformats.org/officeDocument/2006/relationships" id="258" r:id="R31cd1cb8907f4e7a"/>
+    <p:sldId xmlns:r="http://schemas.openxmlformats.org/officeDocument/2006/relationships" id="259" r:id="Rdae29cebe5ff48f9"/>
+    <p:sldId xmlns:r="http://schemas.openxmlformats.org/officeDocument/2006/relationships" id="260" r:id="R1a9d877d358c45b0"/>
+    <p:sldId xmlns:r="http://schemas.openxmlformats.org/officeDocument/2006/relationships" id="261" r:id="R72bf074124b04a1a"/>
+    <p:sldId xmlns:r="http://schemas.openxmlformats.org/officeDocument/2006/relationships" id="262" r:id="Rf6d7aaf2a3fa4e6e"/>
+    <p:sldId xmlns:r="http://schemas.openxmlformats.org/officeDocument/2006/relationships" id="263" r:id="Rba56d1c5c4524f46"/>
+    <p:sldId xmlns:r="http://schemas.openxmlformats.org/officeDocument/2006/relationships" id="264" r:id="R51fbfced3a204ffc"/>
+    <p:sldId xmlns:r="http://schemas.openxmlformats.org/officeDocument/2006/relationships" id="265" r:id="R2dd2a22aa0734b1a"/>
   </p:sldIdLst>
   <p:sldSz cx="12192000" cy="6858000"/>
   <p:notesSz cx="6858000" cy="9144000"/>
@@ -1149,7 +1149,7 @@
   </p:cSld>
   <p:clrMap bg1="lt1" tx1="dk1" bg2="lt2" tx2="dk2" accent1="accent1" accent2="accent2" accent3="accent3" accent4="accent4" accent5="accent5" accent6="accent6" hlink="hlink" folHlink="folHlink"/>
   <p:sldLayoutIdLst>
-    <p:sldLayoutId xmlns:r="http://schemas.openxmlformats.org/officeDocument/2006/relationships" id="2147483649" r:id="R3b9c1532d552456c"/>
+    <p:sldLayoutId xmlns:r="http://schemas.openxmlformats.org/officeDocument/2006/relationships" id="2147483649" r:id="R2e006090e9f74b21"/>
   </p:sldLayoutIdLst>
   <p:txStyles>
     <p:titleStyle>
@@ -1700,7 +1700,7 @@
           <p:cNvPr id="7" name="text-1">
             <a:extLst xmlns:a="http://schemas.openxmlformats.org/drawingml/2006/main">
               <a:ext uri="{FF2B5EF4-FFF2-40B4-BE49-F238E27FC236}">
-                <a16:creationId xmlns:a16="http://schemas.microsoft.com/office/drawing/2014/main" id="{32DB5454-8C08-46C8-8174-F4A74E9FFCC8}"/>
+                <a16:creationId xmlns:a16="http://schemas.microsoft.com/office/drawing/2014/main" id="{8938F0B8-C3DF-456F-90D0-25A26091DCCA}"/>
               </a:ext>
             </a:extLst>
           </p:cNvPr>
@@ -1757,7 +1757,7 @@
           <p:cNvPr id="2" name="text-2">
             <a:extLst xmlns:a="http://schemas.openxmlformats.org/drawingml/2006/main">
               <a:ext uri="{FF2B5EF4-FFF2-40B4-BE49-F238E27FC236}">
-                <a16:creationId xmlns:a16="http://schemas.microsoft.com/office/drawing/2014/main" id="{8CBDE484-F928-4D30-ABCE-279FDD288282}"/>
+                <a16:creationId xmlns:a16="http://schemas.microsoft.com/office/drawing/2014/main" id="{D1E15BB5-F690-4FE8-9769-FF274C611F9A}"/>
               </a:ext>
             </a:extLst>
           </p:cNvPr>
@@ -1814,7 +1814,7 @@
           <p:cNvPr id="3" name="text-3">
             <a:extLst xmlns:a="http://schemas.openxmlformats.org/drawingml/2006/main">
               <a:ext uri="{FF2B5EF4-FFF2-40B4-BE49-F238E27FC236}">
-                <a16:creationId xmlns:a16="http://schemas.microsoft.com/office/drawing/2014/main" id="{349D009F-83A8-4D81-BFB1-F43D4E470C3B}"/>
+                <a16:creationId xmlns:a16="http://schemas.microsoft.com/office/drawing/2014/main" id="{8CBCE219-4AEF-40FC-83BC-2D15FC31635E}"/>
               </a:ext>
             </a:extLst>
           </p:cNvPr>
@@ -1871,7 +1871,7 @@
           <p:cNvPr id="4" name="text-4">
             <a:extLst xmlns:a="http://schemas.openxmlformats.org/drawingml/2006/main">
               <a:ext uri="{FF2B5EF4-FFF2-40B4-BE49-F238E27FC236}">
-                <a16:creationId xmlns:a16="http://schemas.microsoft.com/office/drawing/2014/main" id="{832A51C8-7C7E-46B1-B930-A54CBE58C12C}"/>
+                <a16:creationId xmlns:a16="http://schemas.microsoft.com/office/drawing/2014/main" id="{52C14827-70AE-444A-BC83-152EE3D6987C}"/>
               </a:ext>
             </a:extLst>
           </p:cNvPr>
@@ -1951,7 +1951,7 @@
           <p:cNvPr id="5" name="text-5">
             <a:extLst xmlns:a="http://schemas.openxmlformats.org/drawingml/2006/main">
               <a:ext uri="{FF2B5EF4-FFF2-40B4-BE49-F238E27FC236}">
-                <a16:creationId xmlns:a16="http://schemas.microsoft.com/office/drawing/2014/main" id="{6593E4B3-160B-4FC8-9BA9-4713E0725083}"/>
+                <a16:creationId xmlns:a16="http://schemas.microsoft.com/office/drawing/2014/main" id="{A5B15234-DA69-4768-A56D-4B6A1F325E82}"/>
               </a:ext>
             </a:extLst>
           </p:cNvPr>
@@ -1998,7 +1998,7 @@
                 <a:ea typeface="Apple SD Gothic Neo"/>
                 <a:cs typeface="Apple SD Gothic Neo"/>
               </a:rPr>
-              <a:t>Chrome MV3 확장 · Ethereum 거래 해석 · Groq 전용 설명 경로</a:t>
+              <a:t>Chrome MV3 확장 · Ethereum 거래 해석 · AI API 설명 경로</a:t>
             </a:r>
           </a:p>
         </p:txBody>
@@ -2008,7 +2008,7 @@
           <p:cNvPr id="6" name="text-6">
             <a:extLst xmlns:a="http://schemas.openxmlformats.org/drawingml/2006/main">
               <a:ext uri="{FF2B5EF4-FFF2-40B4-BE49-F238E27FC236}">
-                <a16:creationId xmlns:a16="http://schemas.microsoft.com/office/drawing/2014/main" id="{C88A71E1-6405-43CA-A778-31D351FFBEA5}"/>
+                <a16:creationId xmlns:a16="http://schemas.microsoft.com/office/drawing/2014/main" id="{639CD528-DCE9-4D99-BB48-75DA7BA05762}"/>
               </a:ext>
             </a:extLst>
           </p:cNvPr>
@@ -2055,7 +2055,7 @@
                 <a:ea typeface="Apple SD Gothic Neo"/>
                 <a:cs typeface="Apple SD Gothic Neo"/>
               </a:rPr>
-              <a:t>2인 개발팀 · 2026-09-12</a:t>
+              <a:t>팀 헐크호건 (아주대학교 박건, 가천대학교 서호)</a:t>
             </a:r>
           </a:p>
         </p:txBody>
@@ -2063,7 +2063,7 @@
     </p:spTree>
     <p:extLst>
       <p:ext uri="{BB962C8B-B14F-4D97-AF65-F5344CB8AC3E}">
-        <p14:creationId xmlns:p14="http://schemas.microsoft.com/office/powerpoint/2010/main" val="300849777"/>
+        <p14:creationId xmlns:p14="http://schemas.microsoft.com/office/powerpoint/2010/main" val="165721257"/>
       </p:ext>
     </p:extLst>
   </p:cSld>
@@ -2094,7 +2094,7 @@
           <p:cNvPr id="10" name="text-75">
             <a:extLst xmlns:a="http://schemas.openxmlformats.org/drawingml/2006/main">
               <a:ext uri="{FF2B5EF4-FFF2-40B4-BE49-F238E27FC236}">
-                <a16:creationId xmlns:a16="http://schemas.microsoft.com/office/drawing/2014/main" id="{E44CEDB4-E3D9-464C-897A-0D6D21831B5A}"/>
+                <a16:creationId xmlns:a16="http://schemas.microsoft.com/office/drawing/2014/main" id="{C998D3D7-F833-4503-B8AC-6C954C942361}"/>
               </a:ext>
             </a:extLst>
           </p:cNvPr>
@@ -2151,7 +2151,7 @@
           <p:cNvPr id="2" name="text-76">
             <a:extLst xmlns:a="http://schemas.openxmlformats.org/drawingml/2006/main">
               <a:ext uri="{FF2B5EF4-FFF2-40B4-BE49-F238E27FC236}">
-                <a16:creationId xmlns:a16="http://schemas.microsoft.com/office/drawing/2014/main" id="{5E476421-B132-4E86-BBCD-1AFC833A3F04}"/>
+                <a16:creationId xmlns:a16="http://schemas.microsoft.com/office/drawing/2014/main" id="{4E511964-7463-41C6-A3D8-2F270247E743}"/>
               </a:ext>
             </a:extLst>
           </p:cNvPr>
@@ -2208,7 +2208,7 @@
           <p:cNvPr id="3" name="">
             <a:extLst xmlns:a="http://schemas.openxmlformats.org/drawingml/2006/main">
               <a:ext uri="{FF2B5EF4-FFF2-40B4-BE49-F238E27FC236}">
-                <a16:creationId xmlns:a16="http://schemas.microsoft.com/office/drawing/2014/main" id="{814D8BAF-93BB-49E0-A8CB-7BC1A5627F81}"/>
+                <a16:creationId xmlns:a16="http://schemas.microsoft.com/office/drawing/2014/main" id="{9274261B-73F2-490B-9805-F6CE6A188A01}"/>
               </a:ext>
             </a:extLst>
           </p:cNvPr>
@@ -2238,7 +2238,7 @@
           <p:cNvPr id="4" name="text-77">
             <a:extLst xmlns:a="http://schemas.openxmlformats.org/drawingml/2006/main">
               <a:ext uri="{FF2B5EF4-FFF2-40B4-BE49-F238E27FC236}">
-                <a16:creationId xmlns:a16="http://schemas.microsoft.com/office/drawing/2014/main" id="{05EB1C4F-ED5A-4570-A34E-CDFF63E50FCC}"/>
+                <a16:creationId xmlns:a16="http://schemas.microsoft.com/office/drawing/2014/main" id="{8A6E9B18-6178-4741-995F-7C7EF81819A0}"/>
               </a:ext>
             </a:extLst>
           </p:cNvPr>
@@ -2295,7 +2295,7 @@
           <p:cNvPr id="5" name="text-78">
             <a:extLst xmlns:a="http://schemas.openxmlformats.org/drawingml/2006/main">
               <a:ext uri="{FF2B5EF4-FFF2-40B4-BE49-F238E27FC236}">
-                <a16:creationId xmlns:a16="http://schemas.microsoft.com/office/drawing/2014/main" id="{03D9F15F-CF16-466B-9DC9-913B3944CA6A}"/>
+                <a16:creationId xmlns:a16="http://schemas.microsoft.com/office/drawing/2014/main" id="{B040BDDE-2290-444C-B03F-1749CA20B770}"/>
               </a:ext>
             </a:extLst>
           </p:cNvPr>
@@ -2752,7 +2752,7 @@
           <p:cNvPr id="7" name="text-79">
             <a:extLst xmlns:a="http://schemas.openxmlformats.org/drawingml/2006/main">
               <a:ext uri="{FF2B5EF4-FFF2-40B4-BE49-F238E27FC236}">
-                <a16:creationId xmlns:a16="http://schemas.microsoft.com/office/drawing/2014/main" id="{8D407E07-026E-44C8-B9B4-E818607A654B}"/>
+                <a16:creationId xmlns:a16="http://schemas.microsoft.com/office/drawing/2014/main" id="{D62A1383-C51D-48C2-9046-8DABF9F96934}"/>
               </a:ext>
             </a:extLst>
           </p:cNvPr>
@@ -2809,7 +2809,7 @@
           <p:cNvPr id="8" name="text-80">
             <a:extLst xmlns:a="http://schemas.openxmlformats.org/drawingml/2006/main">
               <a:ext uri="{FF2B5EF4-FFF2-40B4-BE49-F238E27FC236}">
-                <a16:creationId xmlns:a16="http://schemas.microsoft.com/office/drawing/2014/main" id="{B667A7B7-19C8-4895-B04D-B855F769EE4A}"/>
+                <a16:creationId xmlns:a16="http://schemas.microsoft.com/office/drawing/2014/main" id="{4B1A5F9F-71C8-4278-8DAA-054F7363A7C0}"/>
               </a:ext>
             </a:extLst>
           </p:cNvPr>
@@ -2889,7 +2889,7 @@
           <p:cNvPr id="9" name="text-81">
             <a:extLst xmlns:a="http://schemas.openxmlformats.org/drawingml/2006/main">
               <a:ext uri="{FF2B5EF4-FFF2-40B4-BE49-F238E27FC236}">
-                <a16:creationId xmlns:a16="http://schemas.microsoft.com/office/drawing/2014/main" id="{89920BC0-F15B-4F76-A63B-C06323C47FAA}"/>
+                <a16:creationId xmlns:a16="http://schemas.microsoft.com/office/drawing/2014/main" id="{1882BA75-6A8E-4036-BDAE-52244ACA2196}"/>
               </a:ext>
             </a:extLst>
           </p:cNvPr>
@@ -2944,7 +2944,7 @@
     </p:spTree>
     <p:extLst>
       <p:ext uri="{BB962C8B-B14F-4D97-AF65-F5344CB8AC3E}">
-        <p14:creationId xmlns:p14="http://schemas.microsoft.com/office/powerpoint/2010/main" val="241265088"/>
+        <p14:creationId xmlns:p14="http://schemas.microsoft.com/office/powerpoint/2010/main" val="1944919626"/>
       </p:ext>
     </p:extLst>
   </p:cSld>
@@ -2975,7 +2975,7 @@
           <p:cNvPr id="11" name="text-7">
             <a:extLst xmlns:a="http://schemas.openxmlformats.org/drawingml/2006/main">
               <a:ext uri="{FF2B5EF4-FFF2-40B4-BE49-F238E27FC236}">
-                <a16:creationId xmlns:a16="http://schemas.microsoft.com/office/drawing/2014/main" id="{8B152826-AA40-4D46-A8DF-5418DED9FA33}"/>
+                <a16:creationId xmlns:a16="http://schemas.microsoft.com/office/drawing/2014/main" id="{14D4E2FA-CCDB-4EBF-8A6B-235C85C58082}"/>
               </a:ext>
             </a:extLst>
           </p:cNvPr>
@@ -3032,7 +3032,7 @@
           <p:cNvPr id="2" name="text-8">
             <a:extLst xmlns:a="http://schemas.openxmlformats.org/drawingml/2006/main">
               <a:ext uri="{FF2B5EF4-FFF2-40B4-BE49-F238E27FC236}">
-                <a16:creationId xmlns:a16="http://schemas.microsoft.com/office/drawing/2014/main" id="{5270BE6E-BA69-4A21-8D4A-5CFFD2AF874C}"/>
+                <a16:creationId xmlns:a16="http://schemas.microsoft.com/office/drawing/2014/main" id="{56A19275-623A-4C58-B20F-4186F3FB5A13}"/>
               </a:ext>
             </a:extLst>
           </p:cNvPr>
@@ -3089,7 +3089,7 @@
           <p:cNvPr id="3" name="">
             <a:extLst xmlns:a="http://schemas.openxmlformats.org/drawingml/2006/main">
               <a:ext uri="{FF2B5EF4-FFF2-40B4-BE49-F238E27FC236}">
-                <a16:creationId xmlns:a16="http://schemas.microsoft.com/office/drawing/2014/main" id="{DCABF050-0002-404D-8707-2CFBD25D03CB}"/>
+                <a16:creationId xmlns:a16="http://schemas.microsoft.com/office/drawing/2014/main" id="{303C27F6-987E-4D80-995F-34F8988183AE}"/>
               </a:ext>
             </a:extLst>
           </p:cNvPr>
@@ -3119,7 +3119,7 @@
           <p:cNvPr id="4" name="text-9">
             <a:extLst xmlns:a="http://schemas.openxmlformats.org/drawingml/2006/main">
               <a:ext uri="{FF2B5EF4-FFF2-40B4-BE49-F238E27FC236}">
-                <a16:creationId xmlns:a16="http://schemas.microsoft.com/office/drawing/2014/main" id="{79BFB772-0D41-4F66-831A-CFE889AD6111}"/>
+                <a16:creationId xmlns:a16="http://schemas.microsoft.com/office/drawing/2014/main" id="{22C3ABD4-E4F6-4351-838F-7F32D15A1BDB}"/>
               </a:ext>
             </a:extLst>
           </p:cNvPr>
@@ -3176,7 +3176,7 @@
           <p:cNvPr id="5" name="text-10">
             <a:extLst xmlns:a="http://schemas.openxmlformats.org/drawingml/2006/main">
               <a:ext uri="{FF2B5EF4-FFF2-40B4-BE49-F238E27FC236}">
-                <a16:creationId xmlns:a16="http://schemas.microsoft.com/office/drawing/2014/main" id="{814B1265-14C8-4A13-871F-3E02D6A0F9FE}"/>
+                <a16:creationId xmlns:a16="http://schemas.microsoft.com/office/drawing/2014/main" id="{AE95D44D-E342-4C57-B9AC-2D3850475A6A}"/>
               </a:ext>
             </a:extLst>
           </p:cNvPr>
@@ -3233,7 +3233,7 @@
           <p:cNvPr id="6" name="text-11">
             <a:extLst xmlns:a="http://schemas.openxmlformats.org/drawingml/2006/main">
               <a:ext uri="{FF2B5EF4-FFF2-40B4-BE49-F238E27FC236}">
-                <a16:creationId xmlns:a16="http://schemas.microsoft.com/office/drawing/2014/main" id="{75007E33-366B-4A57-9ABE-6FE2AC05175E}"/>
+                <a16:creationId xmlns:a16="http://schemas.microsoft.com/office/drawing/2014/main" id="{B1A704E5-428C-404F-A70D-5909A23C2028}"/>
               </a:ext>
             </a:extLst>
           </p:cNvPr>
@@ -3313,7 +3313,7 @@
           <p:cNvPr id="7" name="text-12">
             <a:extLst xmlns:a="http://schemas.openxmlformats.org/drawingml/2006/main">
               <a:ext uri="{FF2B5EF4-FFF2-40B4-BE49-F238E27FC236}">
-                <a16:creationId xmlns:a16="http://schemas.microsoft.com/office/drawing/2014/main" id="{FBB481DE-F240-47A3-8252-627AD988E6BF}"/>
+                <a16:creationId xmlns:a16="http://schemas.microsoft.com/office/drawing/2014/main" id="{A144AAF3-F44E-49E4-A7A3-DC7DBCC46868}"/>
               </a:ext>
             </a:extLst>
           </p:cNvPr>
@@ -3631,7 +3631,7 @@
           <p:cNvPr id="9" name="text-13">
             <a:extLst xmlns:a="http://schemas.openxmlformats.org/drawingml/2006/main">
               <a:ext uri="{FF2B5EF4-FFF2-40B4-BE49-F238E27FC236}">
-                <a16:creationId xmlns:a16="http://schemas.microsoft.com/office/drawing/2014/main" id="{755AA340-76E2-4FAA-9554-51F0BE1A177D}"/>
+                <a16:creationId xmlns:a16="http://schemas.microsoft.com/office/drawing/2014/main" id="{B0A633C8-64C2-4388-9298-ACA82BF6E31E}"/>
               </a:ext>
             </a:extLst>
           </p:cNvPr>
@@ -3688,7 +3688,7 @@
           <p:cNvPr id="10" name="text-14">
             <a:extLst xmlns:a="http://schemas.openxmlformats.org/drawingml/2006/main">
               <a:ext uri="{FF2B5EF4-FFF2-40B4-BE49-F238E27FC236}">
-                <a16:creationId xmlns:a16="http://schemas.microsoft.com/office/drawing/2014/main" id="{ED3E8D82-1419-4779-B1F7-ECCD053413C6}"/>
+                <a16:creationId xmlns:a16="http://schemas.microsoft.com/office/drawing/2014/main" id="{E777D291-2694-4153-B5F3-69B80A219BC4}"/>
               </a:ext>
             </a:extLst>
           </p:cNvPr>
@@ -3743,7 +3743,7 @@
     </p:spTree>
     <p:extLst>
       <p:ext uri="{BB962C8B-B14F-4D97-AF65-F5344CB8AC3E}">
-        <p14:creationId xmlns:p14="http://schemas.microsoft.com/office/powerpoint/2010/main" val="1219690748"/>
+        <p14:creationId xmlns:p14="http://schemas.microsoft.com/office/powerpoint/2010/main" val="979711710"/>
       </p:ext>
     </p:extLst>
   </p:cSld>
@@ -3774,7 +3774,7 @@
           <p:cNvPr id="10" name="text-15">
             <a:extLst xmlns:a="http://schemas.openxmlformats.org/drawingml/2006/main">
               <a:ext uri="{FF2B5EF4-FFF2-40B4-BE49-F238E27FC236}">
-                <a16:creationId xmlns:a16="http://schemas.microsoft.com/office/drawing/2014/main" id="{4BA10DA5-AAC8-40F2-9FB4-C1451337F39D}"/>
+                <a16:creationId xmlns:a16="http://schemas.microsoft.com/office/drawing/2014/main" id="{26551F94-C085-4A6F-B243-D6222BAADEC7}"/>
               </a:ext>
             </a:extLst>
           </p:cNvPr>
@@ -3831,7 +3831,7 @@
           <p:cNvPr id="2" name="text-16">
             <a:extLst xmlns:a="http://schemas.openxmlformats.org/drawingml/2006/main">
               <a:ext uri="{FF2B5EF4-FFF2-40B4-BE49-F238E27FC236}">
-                <a16:creationId xmlns:a16="http://schemas.microsoft.com/office/drawing/2014/main" id="{AFD054B2-392B-458A-A79B-E9B70D253FAB}"/>
+                <a16:creationId xmlns:a16="http://schemas.microsoft.com/office/drawing/2014/main" id="{EBDE4A1D-9E55-4BBD-9D53-3CAB13C114F2}"/>
               </a:ext>
             </a:extLst>
           </p:cNvPr>
@@ -3888,7 +3888,7 @@
           <p:cNvPr id="3" name="">
             <a:extLst xmlns:a="http://schemas.openxmlformats.org/drawingml/2006/main">
               <a:ext uri="{FF2B5EF4-FFF2-40B4-BE49-F238E27FC236}">
-                <a16:creationId xmlns:a16="http://schemas.microsoft.com/office/drawing/2014/main" id="{426668AA-3160-4A1E-9179-D92F4AC8A334}"/>
+                <a16:creationId xmlns:a16="http://schemas.microsoft.com/office/drawing/2014/main" id="{814CF951-464E-4BEF-ADD0-4EC095E32732}"/>
               </a:ext>
             </a:extLst>
           </p:cNvPr>
@@ -3918,7 +3918,7 @@
           <p:cNvPr id="4" name="text-17">
             <a:extLst xmlns:a="http://schemas.openxmlformats.org/drawingml/2006/main">
               <a:ext uri="{FF2B5EF4-FFF2-40B4-BE49-F238E27FC236}">
-                <a16:creationId xmlns:a16="http://schemas.microsoft.com/office/drawing/2014/main" id="{C87FF68D-B8F7-4F1D-813B-A25FFBEF5908}"/>
+                <a16:creationId xmlns:a16="http://schemas.microsoft.com/office/drawing/2014/main" id="{2D77B32D-F1EB-41BB-A911-AADD28C4AE8C}"/>
               </a:ext>
             </a:extLst>
           </p:cNvPr>
@@ -3975,7 +3975,7 @@
           <p:cNvPr id="5" name="text-18">
             <a:extLst xmlns:a="http://schemas.openxmlformats.org/drawingml/2006/main">
               <a:ext uri="{FF2B5EF4-FFF2-40B4-BE49-F238E27FC236}">
-                <a16:creationId xmlns:a16="http://schemas.microsoft.com/office/drawing/2014/main" id="{777F414D-7466-4AB6-9573-787BF9872993}"/>
+                <a16:creationId xmlns:a16="http://schemas.microsoft.com/office/drawing/2014/main" id="{C5BE1A09-1B0F-4709-8972-72A0AB185B01}"/>
               </a:ext>
             </a:extLst>
           </p:cNvPr>
@@ -4270,7 +4270,7 @@
           <p:cNvPr id="7" name="text-19">
             <a:extLst xmlns:a="http://schemas.openxmlformats.org/drawingml/2006/main">
               <a:ext uri="{FF2B5EF4-FFF2-40B4-BE49-F238E27FC236}">
-                <a16:creationId xmlns:a16="http://schemas.microsoft.com/office/drawing/2014/main" id="{710876F0-328D-4169-A944-392579A62831}"/>
+                <a16:creationId xmlns:a16="http://schemas.microsoft.com/office/drawing/2014/main" id="{5063C486-60B4-4752-9DC9-E4BF7BEF1319}"/>
               </a:ext>
             </a:extLst>
           </p:cNvPr>
@@ -4327,7 +4327,7 @@
           <p:cNvPr id="8" name="text-20">
             <a:extLst xmlns:a="http://schemas.openxmlformats.org/drawingml/2006/main">
               <a:ext uri="{FF2B5EF4-FFF2-40B4-BE49-F238E27FC236}">
-                <a16:creationId xmlns:a16="http://schemas.microsoft.com/office/drawing/2014/main" id="{79519A98-5395-45AD-9E45-2832C6F3076B}"/>
+                <a16:creationId xmlns:a16="http://schemas.microsoft.com/office/drawing/2014/main" id="{9BDB8167-E2F4-4AF7-A524-388FB6404B45}"/>
               </a:ext>
             </a:extLst>
           </p:cNvPr>
@@ -4407,7 +4407,7 @@
           <p:cNvPr id="9" name="text-21">
             <a:extLst xmlns:a="http://schemas.openxmlformats.org/drawingml/2006/main">
               <a:ext uri="{FF2B5EF4-FFF2-40B4-BE49-F238E27FC236}">
-                <a16:creationId xmlns:a16="http://schemas.microsoft.com/office/drawing/2014/main" id="{319C9456-6FD2-4EE2-B7B1-BF2E97CC39C1}"/>
+                <a16:creationId xmlns:a16="http://schemas.microsoft.com/office/drawing/2014/main" id="{7B5AFEFE-9601-430F-AFCA-F2953964A334}"/>
               </a:ext>
             </a:extLst>
           </p:cNvPr>
@@ -4508,7 +4508,7 @@
     </p:spTree>
     <p:extLst>
       <p:ext uri="{BB962C8B-B14F-4D97-AF65-F5344CB8AC3E}">
-        <p14:creationId xmlns:p14="http://schemas.microsoft.com/office/powerpoint/2010/main" val="1008629450"/>
+        <p14:creationId xmlns:p14="http://schemas.microsoft.com/office/powerpoint/2010/main" val="708573235"/>
       </p:ext>
     </p:extLst>
   </p:cSld>
@@ -4539,7 +4539,7 @@
           <p:cNvPr id="18" name="text-22">
             <a:extLst xmlns:a="http://schemas.openxmlformats.org/drawingml/2006/main">
               <a:ext uri="{FF2B5EF4-FFF2-40B4-BE49-F238E27FC236}">
-                <a16:creationId xmlns:a16="http://schemas.microsoft.com/office/drawing/2014/main" id="{BB352260-FD1A-4080-B7C4-017500B1E382}"/>
+                <a16:creationId xmlns:a16="http://schemas.microsoft.com/office/drawing/2014/main" id="{60A17B9C-FC91-49FD-B27B-A406A89CDE15}"/>
               </a:ext>
             </a:extLst>
           </p:cNvPr>
@@ -4596,7 +4596,7 @@
           <p:cNvPr id="2" name="text-23">
             <a:extLst xmlns:a="http://schemas.openxmlformats.org/drawingml/2006/main">
               <a:ext uri="{FF2B5EF4-FFF2-40B4-BE49-F238E27FC236}">
-                <a16:creationId xmlns:a16="http://schemas.microsoft.com/office/drawing/2014/main" id="{5211F680-B3BC-43E9-9BCC-45E2D309A0C8}"/>
+                <a16:creationId xmlns:a16="http://schemas.microsoft.com/office/drawing/2014/main" id="{71708588-AD12-4D93-9AFC-957B26EBCAF5}"/>
               </a:ext>
             </a:extLst>
           </p:cNvPr>
@@ -4653,7 +4653,7 @@
           <p:cNvPr id="3" name="">
             <a:extLst xmlns:a="http://schemas.openxmlformats.org/drawingml/2006/main">
               <a:ext uri="{FF2B5EF4-FFF2-40B4-BE49-F238E27FC236}">
-                <a16:creationId xmlns:a16="http://schemas.microsoft.com/office/drawing/2014/main" id="{28EA7265-F955-4B9E-A8FC-3F055FFF17D7}"/>
+                <a16:creationId xmlns:a16="http://schemas.microsoft.com/office/drawing/2014/main" id="{A20D4C32-A10A-48D9-B0E8-598FE698A777}"/>
               </a:ext>
             </a:extLst>
           </p:cNvPr>
@@ -4683,7 +4683,7 @@
           <p:cNvPr id="4" name="text-24">
             <a:extLst xmlns:a="http://schemas.openxmlformats.org/drawingml/2006/main">
               <a:ext uri="{FF2B5EF4-FFF2-40B4-BE49-F238E27FC236}">
-                <a16:creationId xmlns:a16="http://schemas.microsoft.com/office/drawing/2014/main" id="{371EFBD5-1242-40D4-849A-00676F74F7B4}"/>
+                <a16:creationId xmlns:a16="http://schemas.microsoft.com/office/drawing/2014/main" id="{4BA5A2E1-0269-4B4F-B737-2F0DEED77BDA}"/>
               </a:ext>
             </a:extLst>
           </p:cNvPr>
@@ -4740,7 +4740,7 @@
           <p:cNvPr id="5" name="text-25">
             <a:extLst xmlns:a="http://schemas.openxmlformats.org/drawingml/2006/main">
               <a:ext uri="{FF2B5EF4-FFF2-40B4-BE49-F238E27FC236}">
-                <a16:creationId xmlns:a16="http://schemas.microsoft.com/office/drawing/2014/main" id="{2E547FF0-4512-48E8-B806-95FBCAA81BEE}"/>
+                <a16:creationId xmlns:a16="http://schemas.microsoft.com/office/drawing/2014/main" id="{FF02586C-81DF-438D-889A-F8BDDFA7D418}"/>
               </a:ext>
             </a:extLst>
           </p:cNvPr>
@@ -4801,7 +4801,7 @@
           <p:nvPr/>
         </p:nvPicPr>
         <p:blipFill>
-          <a:blip xmlns:r="http://schemas.openxmlformats.org/officeDocument/2006/relationships" xmlns:a="http://schemas.openxmlformats.org/drawingml/2006/main" r:embed="R0b13db88611045cd"/>
+          <a:blip xmlns:r="http://schemas.openxmlformats.org/officeDocument/2006/relationships" xmlns:a="http://schemas.openxmlformats.org/drawingml/2006/main" r:embed="Ra9260f33c41b4168"/>
           <a:srcRect xmlns:a="http://schemas.openxmlformats.org/drawingml/2006/main" l="77" t="0" r="77" b="0"/>
           <a:stretch xmlns:a="http://schemas.openxmlformats.org/drawingml/2006/main">
             <a:fillRect l="0" t="0" r="0" b="0"/>
@@ -4822,7 +4822,7 @@
           <p:cNvPr id="7" name="text-26">
             <a:extLst xmlns:a="http://schemas.openxmlformats.org/drawingml/2006/main">
               <a:ext uri="{FF2B5EF4-FFF2-40B4-BE49-F238E27FC236}">
-                <a16:creationId xmlns:a16="http://schemas.microsoft.com/office/drawing/2014/main" id="{B28326ED-FCCA-498C-9F6A-A3B9BCF85130}"/>
+                <a16:creationId xmlns:a16="http://schemas.microsoft.com/office/drawing/2014/main" id="{116E48BB-077C-4C2E-B97D-E1550FDE98F5}"/>
               </a:ext>
             </a:extLst>
           </p:cNvPr>
@@ -4879,7 +4879,7 @@
           <p:cNvPr id="8" name="text-27">
             <a:extLst xmlns:a="http://schemas.openxmlformats.org/drawingml/2006/main">
               <a:ext uri="{FF2B5EF4-FFF2-40B4-BE49-F238E27FC236}">
-                <a16:creationId xmlns:a16="http://schemas.microsoft.com/office/drawing/2014/main" id="{7BD98AA2-B9CF-48EA-943B-7B77005D1D20}"/>
+                <a16:creationId xmlns:a16="http://schemas.microsoft.com/office/drawing/2014/main" id="{6406B18C-D583-429C-96F7-330D1041D1FB}"/>
               </a:ext>
             </a:extLst>
           </p:cNvPr>
@@ -4936,7 +4936,7 @@
           <p:cNvPr id="9" name="node-28">
             <a:extLst xmlns:a="http://schemas.openxmlformats.org/drawingml/2006/main">
               <a:ext uri="{FF2B5EF4-FFF2-40B4-BE49-F238E27FC236}">
-                <a16:creationId xmlns:a16="http://schemas.microsoft.com/office/drawing/2014/main" id="{99A13E73-3AF0-45FC-A639-577B91A9B8E6}"/>
+                <a16:creationId xmlns:a16="http://schemas.microsoft.com/office/drawing/2014/main" id="{02A7E981-2BB2-4068-9AA6-A30629439644}"/>
               </a:ext>
             </a:extLst>
           </p:cNvPr>
@@ -5020,7 +5020,7 @@
           <p:cNvPr id="10" name="node-29">
             <a:extLst xmlns:a="http://schemas.openxmlformats.org/drawingml/2006/main">
               <a:ext uri="{FF2B5EF4-FFF2-40B4-BE49-F238E27FC236}">
-                <a16:creationId xmlns:a16="http://schemas.microsoft.com/office/drawing/2014/main" id="{7BEF26A6-3459-48C2-B97E-047144A2E594}"/>
+                <a16:creationId xmlns:a16="http://schemas.microsoft.com/office/drawing/2014/main" id="{7F559502-552F-4A8C-B5AC-E561CAD61C93}"/>
               </a:ext>
             </a:extLst>
           </p:cNvPr>
@@ -5104,7 +5104,7 @@
           <p:cNvPr id="11" name="node-30">
             <a:extLst xmlns:a="http://schemas.openxmlformats.org/drawingml/2006/main">
               <a:ext uri="{FF2B5EF4-FFF2-40B4-BE49-F238E27FC236}">
-                <a16:creationId xmlns:a16="http://schemas.microsoft.com/office/drawing/2014/main" id="{CEFE3D28-0890-480F-9E8E-1E6088FB5E04}"/>
+                <a16:creationId xmlns:a16="http://schemas.microsoft.com/office/drawing/2014/main" id="{8F46939B-22A0-4B0C-B63C-A8583CF30AFD}"/>
               </a:ext>
             </a:extLst>
           </p:cNvPr>
@@ -5211,7 +5211,7 @@
           <p:cNvPr id="12" name="node-31">
             <a:extLst xmlns:a="http://schemas.openxmlformats.org/drawingml/2006/main">
               <a:ext uri="{FF2B5EF4-FFF2-40B4-BE49-F238E27FC236}">
-                <a16:creationId xmlns:a16="http://schemas.microsoft.com/office/drawing/2014/main" id="{4BE7B9CF-BF85-4670-8690-9D89DA4A55EA}"/>
+                <a16:creationId xmlns:a16="http://schemas.microsoft.com/office/drawing/2014/main" id="{1AE05503-C1B7-451F-8F7D-DA06F69FBD5D}"/>
               </a:ext>
             </a:extLst>
           </p:cNvPr>
@@ -5393,7 +5393,7 @@
           <p:cNvPr id="16" name="text-32">
             <a:extLst xmlns:a="http://schemas.openxmlformats.org/drawingml/2006/main">
               <a:ext uri="{FF2B5EF4-FFF2-40B4-BE49-F238E27FC236}">
-                <a16:creationId xmlns:a16="http://schemas.microsoft.com/office/drawing/2014/main" id="{2179D64C-D302-4DE0-9B8E-69084960EBFA}"/>
+                <a16:creationId xmlns:a16="http://schemas.microsoft.com/office/drawing/2014/main" id="{1CDE1377-3696-4886-994C-239F9B672410}"/>
               </a:ext>
             </a:extLst>
           </p:cNvPr>
@@ -5496,7 +5496,7 @@
           <p:cNvPr id="17" name="text-33">
             <a:extLst xmlns:a="http://schemas.openxmlformats.org/drawingml/2006/main">
               <a:ext uri="{FF2B5EF4-FFF2-40B4-BE49-F238E27FC236}">
-                <a16:creationId xmlns:a16="http://schemas.microsoft.com/office/drawing/2014/main" id="{A59ED820-8D2B-4382-8652-65585879CB83}"/>
+                <a16:creationId xmlns:a16="http://schemas.microsoft.com/office/drawing/2014/main" id="{8C8AA2B4-DD25-430A-A867-5D36CAAAFBF6}"/>
               </a:ext>
             </a:extLst>
           </p:cNvPr>
@@ -5551,7 +5551,7 @@
     </p:spTree>
     <p:extLst>
       <p:ext uri="{BB962C8B-B14F-4D97-AF65-F5344CB8AC3E}">
-        <p14:creationId xmlns:p14="http://schemas.microsoft.com/office/powerpoint/2010/main" val="1950495232"/>
+        <p14:creationId xmlns:p14="http://schemas.microsoft.com/office/powerpoint/2010/main" val="331355143"/>
       </p:ext>
     </p:extLst>
   </p:cSld>
@@ -5582,7 +5582,7 @@
           <p:cNvPr id="9" name="text-34">
             <a:extLst xmlns:a="http://schemas.openxmlformats.org/drawingml/2006/main">
               <a:ext uri="{FF2B5EF4-FFF2-40B4-BE49-F238E27FC236}">
-                <a16:creationId xmlns:a16="http://schemas.microsoft.com/office/drawing/2014/main" id="{019D9175-8A39-4258-8C29-3B9DE0F8C41C}"/>
+                <a16:creationId xmlns:a16="http://schemas.microsoft.com/office/drawing/2014/main" id="{71315F94-B0BB-4A1C-BE81-7D41159634FA}"/>
               </a:ext>
             </a:extLst>
           </p:cNvPr>
@@ -5639,7 +5639,7 @@
           <p:cNvPr id="2" name="text-35">
             <a:extLst xmlns:a="http://schemas.openxmlformats.org/drawingml/2006/main">
               <a:ext uri="{FF2B5EF4-FFF2-40B4-BE49-F238E27FC236}">
-                <a16:creationId xmlns:a16="http://schemas.microsoft.com/office/drawing/2014/main" id="{AE884E12-C8E7-4282-AD3C-9F13450DF00C}"/>
+                <a16:creationId xmlns:a16="http://schemas.microsoft.com/office/drawing/2014/main" id="{88184FA1-9127-47F9-A42D-8FB02156CA5C}"/>
               </a:ext>
             </a:extLst>
           </p:cNvPr>
@@ -5696,7 +5696,7 @@
           <p:cNvPr id="3" name="">
             <a:extLst xmlns:a="http://schemas.openxmlformats.org/drawingml/2006/main">
               <a:ext uri="{FF2B5EF4-FFF2-40B4-BE49-F238E27FC236}">
-                <a16:creationId xmlns:a16="http://schemas.microsoft.com/office/drawing/2014/main" id="{1594AFAF-1933-408A-97B7-D7877B153CD4}"/>
+                <a16:creationId xmlns:a16="http://schemas.microsoft.com/office/drawing/2014/main" id="{52D971D7-7057-4910-8474-4AF956C705DB}"/>
               </a:ext>
             </a:extLst>
           </p:cNvPr>
@@ -5726,7 +5726,7 @@
           <p:cNvPr id="4" name="text-36">
             <a:extLst xmlns:a="http://schemas.openxmlformats.org/drawingml/2006/main">
               <a:ext uri="{FF2B5EF4-FFF2-40B4-BE49-F238E27FC236}">
-                <a16:creationId xmlns:a16="http://schemas.microsoft.com/office/drawing/2014/main" id="{3EF23EC5-2FB1-478B-9E25-79C456CE0896}"/>
+                <a16:creationId xmlns:a16="http://schemas.microsoft.com/office/drawing/2014/main" id="{490ACF52-D310-4CF6-A767-4F0F2D1D18EC}"/>
               </a:ext>
             </a:extLst>
           </p:cNvPr>
@@ -5783,7 +5783,7 @@
           <p:cNvPr id="5" name="text-37">
             <a:extLst xmlns:a="http://schemas.openxmlformats.org/drawingml/2006/main">
               <a:ext uri="{FF2B5EF4-FFF2-40B4-BE49-F238E27FC236}">
-                <a16:creationId xmlns:a16="http://schemas.microsoft.com/office/drawing/2014/main" id="{1FAC446E-B572-43F5-B231-64EBA4EC0DA2}"/>
+                <a16:creationId xmlns:a16="http://schemas.microsoft.com/office/drawing/2014/main" id="{57E8B0CB-B68E-4DB2-A981-5CBD7C2BFC69}"/>
               </a:ext>
             </a:extLst>
           </p:cNvPr>
@@ -6183,7 +6183,7 @@
           <p:cNvPr id="7" name="text-38">
             <a:extLst xmlns:a="http://schemas.openxmlformats.org/drawingml/2006/main">
               <a:ext uri="{FF2B5EF4-FFF2-40B4-BE49-F238E27FC236}">
-                <a16:creationId xmlns:a16="http://schemas.microsoft.com/office/drawing/2014/main" id="{71923CF4-4847-42E7-B605-84D294E4468B}"/>
+                <a16:creationId xmlns:a16="http://schemas.microsoft.com/office/drawing/2014/main" id="{27D7C2B9-401C-4AD4-A59D-2C9824DFBDD9}"/>
               </a:ext>
             </a:extLst>
           </p:cNvPr>
@@ -6240,7 +6240,7 @@
           <p:cNvPr id="8" name="text-39">
             <a:extLst xmlns:a="http://schemas.openxmlformats.org/drawingml/2006/main">
               <a:ext uri="{FF2B5EF4-FFF2-40B4-BE49-F238E27FC236}">
-                <a16:creationId xmlns:a16="http://schemas.microsoft.com/office/drawing/2014/main" id="{FE51E62D-D998-4661-B62B-805ACFCEC26D}"/>
+                <a16:creationId xmlns:a16="http://schemas.microsoft.com/office/drawing/2014/main" id="{0E3861E7-E334-477F-9BB2-B61109E6D72A}"/>
               </a:ext>
             </a:extLst>
           </p:cNvPr>
@@ -6295,7 +6295,7 @@
     </p:spTree>
     <p:extLst>
       <p:ext uri="{BB962C8B-B14F-4D97-AF65-F5344CB8AC3E}">
-        <p14:creationId xmlns:p14="http://schemas.microsoft.com/office/powerpoint/2010/main" val="1368655410"/>
+        <p14:creationId xmlns:p14="http://schemas.microsoft.com/office/powerpoint/2010/main" val="369053783"/>
       </p:ext>
     </p:extLst>
   </p:cSld>
@@ -6326,7 +6326,7 @@
           <p:cNvPr id="18" name="text-40">
             <a:extLst xmlns:a="http://schemas.openxmlformats.org/drawingml/2006/main">
               <a:ext uri="{FF2B5EF4-FFF2-40B4-BE49-F238E27FC236}">
-                <a16:creationId xmlns:a16="http://schemas.microsoft.com/office/drawing/2014/main" id="{829AFAF1-1519-493B-814B-6E58D815C3FB}"/>
+                <a16:creationId xmlns:a16="http://schemas.microsoft.com/office/drawing/2014/main" id="{93D90FDF-FA1D-4710-A34C-1B4F85E3AE96}"/>
               </a:ext>
             </a:extLst>
           </p:cNvPr>
@@ -6383,7 +6383,7 @@
           <p:cNvPr id="2" name="text-41">
             <a:extLst xmlns:a="http://schemas.openxmlformats.org/drawingml/2006/main">
               <a:ext uri="{FF2B5EF4-FFF2-40B4-BE49-F238E27FC236}">
-                <a16:creationId xmlns:a16="http://schemas.microsoft.com/office/drawing/2014/main" id="{4537D3EE-AEE6-4DF6-8F47-6F9BCE13E25D}"/>
+                <a16:creationId xmlns:a16="http://schemas.microsoft.com/office/drawing/2014/main" id="{7958669B-A1B0-4E7A-A99C-95D52F068829}"/>
               </a:ext>
             </a:extLst>
           </p:cNvPr>
@@ -6440,7 +6440,7 @@
           <p:cNvPr id="3" name="">
             <a:extLst xmlns:a="http://schemas.openxmlformats.org/drawingml/2006/main">
               <a:ext uri="{FF2B5EF4-FFF2-40B4-BE49-F238E27FC236}">
-                <a16:creationId xmlns:a16="http://schemas.microsoft.com/office/drawing/2014/main" id="{094D999A-6356-48E3-95A1-192E5C22DE8D}"/>
+                <a16:creationId xmlns:a16="http://schemas.microsoft.com/office/drawing/2014/main" id="{0C258B0F-DFAB-406F-A24C-F4CA05E1A6F3}"/>
               </a:ext>
             </a:extLst>
           </p:cNvPr>
@@ -6470,7 +6470,7 @@
           <p:cNvPr id="4" name="text-42">
             <a:extLst xmlns:a="http://schemas.openxmlformats.org/drawingml/2006/main">
               <a:ext uri="{FF2B5EF4-FFF2-40B4-BE49-F238E27FC236}">
-                <a16:creationId xmlns:a16="http://schemas.microsoft.com/office/drawing/2014/main" id="{6DA85D1A-6347-484D-940D-C1563A347298}"/>
+                <a16:creationId xmlns:a16="http://schemas.microsoft.com/office/drawing/2014/main" id="{FA89A8AB-0E8F-4130-89A0-724BAAAE2371}"/>
               </a:ext>
             </a:extLst>
           </p:cNvPr>
@@ -6527,7 +6527,7 @@
           <p:cNvPr id="5" name="text-43">
             <a:extLst xmlns:a="http://schemas.openxmlformats.org/drawingml/2006/main">
               <a:ext uri="{FF2B5EF4-FFF2-40B4-BE49-F238E27FC236}">
-                <a16:creationId xmlns:a16="http://schemas.microsoft.com/office/drawing/2014/main" id="{67F6B8AA-7F76-4342-8E6E-37A2C1435203}"/>
+                <a16:creationId xmlns:a16="http://schemas.microsoft.com/office/drawing/2014/main" id="{EC61ECD8-5E04-4732-BB21-53F3DF603C24}"/>
               </a:ext>
             </a:extLst>
           </p:cNvPr>
@@ -6584,7 +6584,7 @@
           <p:cNvPr id="6" name="node-44">
             <a:extLst xmlns:a="http://schemas.openxmlformats.org/drawingml/2006/main">
               <a:ext uri="{FF2B5EF4-FFF2-40B4-BE49-F238E27FC236}">
-                <a16:creationId xmlns:a16="http://schemas.microsoft.com/office/drawing/2014/main" id="{BD7A8868-961C-4B6E-9998-8DF15097DC3A}"/>
+                <a16:creationId xmlns:a16="http://schemas.microsoft.com/office/drawing/2014/main" id="{671B8377-8A7C-44FF-8698-BFB30C531D08}"/>
               </a:ext>
             </a:extLst>
           </p:cNvPr>
@@ -6668,7 +6668,7 @@
           <p:cNvPr id="7" name="node-45">
             <a:extLst xmlns:a="http://schemas.openxmlformats.org/drawingml/2006/main">
               <a:ext uri="{FF2B5EF4-FFF2-40B4-BE49-F238E27FC236}">
-                <a16:creationId xmlns:a16="http://schemas.microsoft.com/office/drawing/2014/main" id="{9BEBEF5A-0179-47BA-A602-A136878F47EE}"/>
+                <a16:creationId xmlns:a16="http://schemas.microsoft.com/office/drawing/2014/main" id="{7BCAAAEA-1CDE-4974-B853-EFDEF729D740}"/>
               </a:ext>
             </a:extLst>
           </p:cNvPr>
@@ -6752,7 +6752,7 @@
           <p:cNvPr id="8" name="node-46">
             <a:extLst xmlns:a="http://schemas.openxmlformats.org/drawingml/2006/main">
               <a:ext uri="{FF2B5EF4-FFF2-40B4-BE49-F238E27FC236}">
-                <a16:creationId xmlns:a16="http://schemas.microsoft.com/office/drawing/2014/main" id="{A3509523-157D-4D74-9492-0DDB5021C27C}"/>
+                <a16:creationId xmlns:a16="http://schemas.microsoft.com/office/drawing/2014/main" id="{53FF9727-BFB1-4553-86BC-732D8ADDC332}"/>
               </a:ext>
             </a:extLst>
           </p:cNvPr>
@@ -6836,7 +6836,7 @@
           <p:cNvPr id="9" name="node-47">
             <a:extLst xmlns:a="http://schemas.openxmlformats.org/drawingml/2006/main">
               <a:ext uri="{FF2B5EF4-FFF2-40B4-BE49-F238E27FC236}">
-                <a16:creationId xmlns:a16="http://schemas.microsoft.com/office/drawing/2014/main" id="{2454BE1D-6FD4-419E-A1BC-2B5F39B962AB}"/>
+                <a16:creationId xmlns:a16="http://schemas.microsoft.com/office/drawing/2014/main" id="{56E12569-9A8B-4F4C-A775-7951C0AE2769}"/>
               </a:ext>
             </a:extLst>
           </p:cNvPr>
@@ -6920,7 +6920,7 @@
           <p:cNvPr id="10" name="node-48">
             <a:extLst xmlns:a="http://schemas.openxmlformats.org/drawingml/2006/main">
               <a:ext uri="{FF2B5EF4-FFF2-40B4-BE49-F238E27FC236}">
-                <a16:creationId xmlns:a16="http://schemas.microsoft.com/office/drawing/2014/main" id="{D29D1DBE-7438-4A46-95E5-2B8E2AEC7A8E}"/>
+                <a16:creationId xmlns:a16="http://schemas.microsoft.com/office/drawing/2014/main" id="{AF8E6546-3FA9-4D8D-A5A5-8061C6E8427A}"/>
               </a:ext>
             </a:extLst>
           </p:cNvPr>
@@ -7004,7 +7004,7 @@
           <p:cNvPr id="11" name="node-49">
             <a:extLst xmlns:a="http://schemas.openxmlformats.org/drawingml/2006/main">
               <a:ext uri="{FF2B5EF4-FFF2-40B4-BE49-F238E27FC236}">
-                <a16:creationId xmlns:a16="http://schemas.microsoft.com/office/drawing/2014/main" id="{2AF5A934-12C3-44F4-B302-CE65733ACE08}"/>
+                <a16:creationId xmlns:a16="http://schemas.microsoft.com/office/drawing/2014/main" id="{0738CE40-90BE-4B8E-AEA1-A1A6FC0F88A8}"/>
               </a:ext>
             </a:extLst>
           </p:cNvPr>
@@ -7213,7 +7213,7 @@
           <p:cNvPr id="17" name="text-50">
             <a:extLst xmlns:a="http://schemas.openxmlformats.org/drawingml/2006/main">
               <a:ext uri="{FF2B5EF4-FFF2-40B4-BE49-F238E27FC236}">
-                <a16:creationId xmlns:a16="http://schemas.microsoft.com/office/drawing/2014/main" id="{D8FCA1DD-9112-4B0D-9348-29A038761C12}"/>
+                <a16:creationId xmlns:a16="http://schemas.microsoft.com/office/drawing/2014/main" id="{66C24916-B3E7-4CF7-A015-8154A00DE0D4}"/>
               </a:ext>
             </a:extLst>
           </p:cNvPr>
@@ -7268,7 +7268,7 @@
     </p:spTree>
     <p:extLst>
       <p:ext uri="{BB962C8B-B14F-4D97-AF65-F5344CB8AC3E}">
-        <p14:creationId xmlns:p14="http://schemas.microsoft.com/office/powerpoint/2010/main" val="1433112032"/>
+        <p14:creationId xmlns:p14="http://schemas.microsoft.com/office/powerpoint/2010/main" val="829697646"/>
       </p:ext>
     </p:extLst>
   </p:cSld>
@@ -7299,7 +7299,7 @@
           <p:cNvPr id="14" name="text-51">
             <a:extLst xmlns:a="http://schemas.openxmlformats.org/drawingml/2006/main">
               <a:ext uri="{FF2B5EF4-FFF2-40B4-BE49-F238E27FC236}">
-                <a16:creationId xmlns:a16="http://schemas.microsoft.com/office/drawing/2014/main" id="{B7919AFB-7067-4C9F-8120-E55EF602F64C}"/>
+                <a16:creationId xmlns:a16="http://schemas.microsoft.com/office/drawing/2014/main" id="{4F89C720-223F-4642-9D61-BF5553DA97E6}"/>
               </a:ext>
             </a:extLst>
           </p:cNvPr>
@@ -7356,7 +7356,7 @@
           <p:cNvPr id="2" name="text-52">
             <a:extLst xmlns:a="http://schemas.openxmlformats.org/drawingml/2006/main">
               <a:ext uri="{FF2B5EF4-FFF2-40B4-BE49-F238E27FC236}">
-                <a16:creationId xmlns:a16="http://schemas.microsoft.com/office/drawing/2014/main" id="{0ACC46E5-2E20-423E-AA40-32EFA2B82A7B}"/>
+                <a16:creationId xmlns:a16="http://schemas.microsoft.com/office/drawing/2014/main" id="{7D9F2B74-5397-4B77-8ADB-7D7A02F8B712}"/>
               </a:ext>
             </a:extLst>
           </p:cNvPr>
@@ -7413,7 +7413,7 @@
           <p:cNvPr id="3" name="">
             <a:extLst xmlns:a="http://schemas.openxmlformats.org/drawingml/2006/main">
               <a:ext uri="{FF2B5EF4-FFF2-40B4-BE49-F238E27FC236}">
-                <a16:creationId xmlns:a16="http://schemas.microsoft.com/office/drawing/2014/main" id="{DA648700-30D0-493B-8CAD-A14DDB9C9410}"/>
+                <a16:creationId xmlns:a16="http://schemas.microsoft.com/office/drawing/2014/main" id="{C87438E7-7B99-417B-9384-EF41B20FF0A4}"/>
               </a:ext>
             </a:extLst>
           </p:cNvPr>
@@ -7443,7 +7443,7 @@
           <p:cNvPr id="4" name="text-53">
             <a:extLst xmlns:a="http://schemas.openxmlformats.org/drawingml/2006/main">
               <a:ext uri="{FF2B5EF4-FFF2-40B4-BE49-F238E27FC236}">
-                <a16:creationId xmlns:a16="http://schemas.microsoft.com/office/drawing/2014/main" id="{D7C524BF-D36F-4768-8569-E05211CBA86F}"/>
+                <a16:creationId xmlns:a16="http://schemas.microsoft.com/office/drawing/2014/main" id="{ABF1C3EA-EC6A-4245-9B1A-AEF495508392}"/>
               </a:ext>
             </a:extLst>
           </p:cNvPr>
@@ -7500,7 +7500,7 @@
           <p:cNvPr id="5" name="text-54">
             <a:extLst xmlns:a="http://schemas.openxmlformats.org/drawingml/2006/main">
               <a:ext uri="{FF2B5EF4-FFF2-40B4-BE49-F238E27FC236}">
-                <a16:creationId xmlns:a16="http://schemas.microsoft.com/office/drawing/2014/main" id="{B46A990A-03FE-4244-BBEA-869FFA691B59}"/>
+                <a16:creationId xmlns:a16="http://schemas.microsoft.com/office/drawing/2014/main" id="{238C69D9-02CB-4D08-B99F-8CD6DC89D854}"/>
               </a:ext>
             </a:extLst>
           </p:cNvPr>
@@ -7557,7 +7557,7 @@
           <p:cNvPr id="6" name="">
             <a:extLst xmlns:a="http://schemas.openxmlformats.org/drawingml/2006/main">
               <a:ext uri="{FF2B5EF4-FFF2-40B4-BE49-F238E27FC236}">
-                <a16:creationId xmlns:a16="http://schemas.microsoft.com/office/drawing/2014/main" id="{05F3D8A9-D976-4920-98C7-3C666DAA71CA}"/>
+                <a16:creationId xmlns:a16="http://schemas.microsoft.com/office/drawing/2014/main" id="{BB1C7ED2-68EB-4A43-9A19-69026A011838}"/>
               </a:ext>
             </a:extLst>
           </p:cNvPr>
@@ -7587,7 +7587,7 @@
           <p:cNvPr id="7" name="text-55">
             <a:extLst xmlns:a="http://schemas.openxmlformats.org/drawingml/2006/main">
               <a:ext uri="{FF2B5EF4-FFF2-40B4-BE49-F238E27FC236}">
-                <a16:creationId xmlns:a16="http://schemas.microsoft.com/office/drawing/2014/main" id="{8F8AC20F-3644-42F7-8035-1D5015FD5D07}"/>
+                <a16:creationId xmlns:a16="http://schemas.microsoft.com/office/drawing/2014/main" id="{8D99C85E-032B-4EDB-A22D-3C1768ADC1A5}"/>
               </a:ext>
             </a:extLst>
           </p:cNvPr>
@@ -7644,7 +7644,7 @@
           <p:cNvPr id="8" name="text-56">
             <a:extLst xmlns:a="http://schemas.openxmlformats.org/drawingml/2006/main">
               <a:ext uri="{FF2B5EF4-FFF2-40B4-BE49-F238E27FC236}">
-                <a16:creationId xmlns:a16="http://schemas.microsoft.com/office/drawing/2014/main" id="{BBE2D713-1EAF-46B1-BF16-D4C4B4E6AC84}"/>
+                <a16:creationId xmlns:a16="http://schemas.microsoft.com/office/drawing/2014/main" id="{AA906953-768A-4A1D-B8D4-43FACBC51430}"/>
               </a:ext>
             </a:extLst>
           </p:cNvPr>
@@ -7701,7 +7701,7 @@
           <p:cNvPr id="9" name="text-57">
             <a:extLst xmlns:a="http://schemas.openxmlformats.org/drawingml/2006/main">
               <a:ext uri="{FF2B5EF4-FFF2-40B4-BE49-F238E27FC236}">
-                <a16:creationId xmlns:a16="http://schemas.microsoft.com/office/drawing/2014/main" id="{E7690790-43ED-44E5-ACB5-3F92BF7F3EB1}"/>
+                <a16:creationId xmlns:a16="http://schemas.microsoft.com/office/drawing/2014/main" id="{A76ADC36-8F99-4595-92C9-0F7687AD5439}"/>
               </a:ext>
             </a:extLst>
           </p:cNvPr>
@@ -7827,7 +7827,7 @@
           <p:cNvPr id="10" name="text-58">
             <a:extLst xmlns:a="http://schemas.openxmlformats.org/drawingml/2006/main">
               <a:ext uri="{FF2B5EF4-FFF2-40B4-BE49-F238E27FC236}">
-                <a16:creationId xmlns:a16="http://schemas.microsoft.com/office/drawing/2014/main" id="{ADB1630B-A2C2-43CB-B344-69980F710D1E}"/>
+                <a16:creationId xmlns:a16="http://schemas.microsoft.com/office/drawing/2014/main" id="{8875DA19-AA16-4EC2-9F0A-692B51DE66CF}"/>
               </a:ext>
             </a:extLst>
           </p:cNvPr>
@@ -7953,7 +7953,7 @@
           <p:cNvPr id="11" name="">
             <a:extLst xmlns:a="http://schemas.openxmlformats.org/drawingml/2006/main">
               <a:ext uri="{FF2B5EF4-FFF2-40B4-BE49-F238E27FC236}">
-                <a16:creationId xmlns:a16="http://schemas.microsoft.com/office/drawing/2014/main" id="{7FC2385F-4126-43E9-B597-93430BF53F11}"/>
+                <a16:creationId xmlns:a16="http://schemas.microsoft.com/office/drawing/2014/main" id="{D5447E67-E12A-4812-B3C0-584F0C4E4F12}"/>
               </a:ext>
             </a:extLst>
           </p:cNvPr>
@@ -7983,7 +7983,7 @@
           <p:cNvPr id="12" name="text-59">
             <a:extLst xmlns:a="http://schemas.openxmlformats.org/drawingml/2006/main">
               <a:ext uri="{FF2B5EF4-FFF2-40B4-BE49-F238E27FC236}">
-                <a16:creationId xmlns:a16="http://schemas.microsoft.com/office/drawing/2014/main" id="{F7551FA3-FE9C-40CD-A744-9245B6B4468E}"/>
+                <a16:creationId xmlns:a16="http://schemas.microsoft.com/office/drawing/2014/main" id="{7FCC7861-471F-41F5-A36F-55A9BD329F16}"/>
               </a:ext>
             </a:extLst>
           </p:cNvPr>
@@ -8040,7 +8040,7 @@
           <p:cNvPr id="13" name="text-60">
             <a:extLst xmlns:a="http://schemas.openxmlformats.org/drawingml/2006/main">
               <a:ext uri="{FF2B5EF4-FFF2-40B4-BE49-F238E27FC236}">
-                <a16:creationId xmlns:a16="http://schemas.microsoft.com/office/drawing/2014/main" id="{484F9E2E-D845-4603-86FC-68D76A261801}"/>
+                <a16:creationId xmlns:a16="http://schemas.microsoft.com/office/drawing/2014/main" id="{65D2AD1E-9626-4DAA-B82E-3DE7A80C8518}"/>
               </a:ext>
             </a:extLst>
           </p:cNvPr>
@@ -8118,7 +8118,7 @@
     </p:spTree>
     <p:extLst>
       <p:ext uri="{BB962C8B-B14F-4D97-AF65-F5344CB8AC3E}">
-        <p14:creationId xmlns:p14="http://schemas.microsoft.com/office/powerpoint/2010/main" val="2075352061"/>
+        <p14:creationId xmlns:p14="http://schemas.microsoft.com/office/powerpoint/2010/main" val="1280557009"/>
       </p:ext>
     </p:extLst>
   </p:cSld>
@@ -8149,7 +8149,7 @@
           <p:cNvPr id="10" name="text-61">
             <a:extLst xmlns:a="http://schemas.openxmlformats.org/drawingml/2006/main">
               <a:ext uri="{FF2B5EF4-FFF2-40B4-BE49-F238E27FC236}">
-                <a16:creationId xmlns:a16="http://schemas.microsoft.com/office/drawing/2014/main" id="{D15A5E8B-7EF9-4576-A91E-B035B2C06C0E}"/>
+                <a16:creationId xmlns:a16="http://schemas.microsoft.com/office/drawing/2014/main" id="{D48A1FB8-2AFE-4290-ACCE-57797860D600}"/>
               </a:ext>
             </a:extLst>
           </p:cNvPr>
@@ -8206,7 +8206,7 @@
           <p:cNvPr id="2" name="text-62">
             <a:extLst xmlns:a="http://schemas.openxmlformats.org/drawingml/2006/main">
               <a:ext uri="{FF2B5EF4-FFF2-40B4-BE49-F238E27FC236}">
-                <a16:creationId xmlns:a16="http://schemas.microsoft.com/office/drawing/2014/main" id="{486DCC52-EB17-4DA0-A4DA-CA20D90FEEC2}"/>
+                <a16:creationId xmlns:a16="http://schemas.microsoft.com/office/drawing/2014/main" id="{AD176BB0-727C-4B4F-9BD9-7B718A7BEC8D}"/>
               </a:ext>
             </a:extLst>
           </p:cNvPr>
@@ -8263,7 +8263,7 @@
           <p:cNvPr id="3" name="">
             <a:extLst xmlns:a="http://schemas.openxmlformats.org/drawingml/2006/main">
               <a:ext uri="{FF2B5EF4-FFF2-40B4-BE49-F238E27FC236}">
-                <a16:creationId xmlns:a16="http://schemas.microsoft.com/office/drawing/2014/main" id="{DDB3A196-AF77-4B36-893A-9825EA7A9DB4}"/>
+                <a16:creationId xmlns:a16="http://schemas.microsoft.com/office/drawing/2014/main" id="{D73B496A-BDAC-45EC-A0DA-280254160C13}"/>
               </a:ext>
             </a:extLst>
           </p:cNvPr>
@@ -8293,7 +8293,7 @@
           <p:cNvPr id="4" name="text-63">
             <a:extLst xmlns:a="http://schemas.openxmlformats.org/drawingml/2006/main">
               <a:ext uri="{FF2B5EF4-FFF2-40B4-BE49-F238E27FC236}">
-                <a16:creationId xmlns:a16="http://schemas.microsoft.com/office/drawing/2014/main" id="{B5E1F874-1A7E-48AB-B508-F5FC582B8058}"/>
+                <a16:creationId xmlns:a16="http://schemas.microsoft.com/office/drawing/2014/main" id="{6693D1C8-422C-45E6-B3D7-7150F9FAE192}"/>
               </a:ext>
             </a:extLst>
           </p:cNvPr>
@@ -8350,7 +8350,7 @@
           <p:cNvPr id="5" name="text-64">
             <a:extLst xmlns:a="http://schemas.openxmlformats.org/drawingml/2006/main">
               <a:ext uri="{FF2B5EF4-FFF2-40B4-BE49-F238E27FC236}">
-                <a16:creationId xmlns:a16="http://schemas.microsoft.com/office/drawing/2014/main" id="{9DDF8592-2140-46D4-9EFA-57674C775FAC}"/>
+                <a16:creationId xmlns:a16="http://schemas.microsoft.com/office/drawing/2014/main" id="{DC9C2F3D-D0F8-456C-A085-1F2C3ABCC886}"/>
               </a:ext>
             </a:extLst>
           </p:cNvPr>
@@ -8750,7 +8750,7 @@
           <p:cNvPr id="7" name="text-65">
             <a:extLst xmlns:a="http://schemas.openxmlformats.org/drawingml/2006/main">
               <a:ext uri="{FF2B5EF4-FFF2-40B4-BE49-F238E27FC236}">
-                <a16:creationId xmlns:a16="http://schemas.microsoft.com/office/drawing/2014/main" id="{03486338-9520-4486-B2F4-6A88AEF66216}"/>
+                <a16:creationId xmlns:a16="http://schemas.microsoft.com/office/drawing/2014/main" id="{1E1C49F2-6814-4ED1-986D-6AB21F406A6F}"/>
               </a:ext>
             </a:extLst>
           </p:cNvPr>
@@ -8807,7 +8807,7 @@
           <p:cNvPr id="8" name="text-66">
             <a:extLst xmlns:a="http://schemas.openxmlformats.org/drawingml/2006/main">
               <a:ext uri="{FF2B5EF4-FFF2-40B4-BE49-F238E27FC236}">
-                <a16:creationId xmlns:a16="http://schemas.microsoft.com/office/drawing/2014/main" id="{8128AD68-C380-4018-AB91-AB5E6AE47538}"/>
+                <a16:creationId xmlns:a16="http://schemas.microsoft.com/office/drawing/2014/main" id="{9073D752-EE4C-4116-9FB0-6118BDAC9AD5}"/>
               </a:ext>
             </a:extLst>
           </p:cNvPr>
@@ -8864,7 +8864,7 @@
           <p:cNvPr id="9" name="text-67">
             <a:extLst xmlns:a="http://schemas.openxmlformats.org/drawingml/2006/main">
               <a:ext uri="{FF2B5EF4-FFF2-40B4-BE49-F238E27FC236}">
-                <a16:creationId xmlns:a16="http://schemas.microsoft.com/office/drawing/2014/main" id="{EBEC6A1D-189A-4267-BE53-A7CBC9929F13}"/>
+                <a16:creationId xmlns:a16="http://schemas.microsoft.com/office/drawing/2014/main" id="{F1F5F033-F427-47AA-A674-E8DE23EFAECF}"/>
               </a:ext>
             </a:extLst>
           </p:cNvPr>
@@ -8919,7 +8919,7 @@
     </p:spTree>
     <p:extLst>
       <p:ext uri="{BB962C8B-B14F-4D97-AF65-F5344CB8AC3E}">
-        <p14:creationId xmlns:p14="http://schemas.microsoft.com/office/powerpoint/2010/main" val="1057212451"/>
+        <p14:creationId xmlns:p14="http://schemas.microsoft.com/office/powerpoint/2010/main" val="563326393"/>
       </p:ext>
     </p:extLst>
   </p:cSld>
@@ -8950,7 +8950,7 @@
           <p:cNvPr id="10" name="text-68">
             <a:extLst xmlns:a="http://schemas.openxmlformats.org/drawingml/2006/main">
               <a:ext uri="{FF2B5EF4-FFF2-40B4-BE49-F238E27FC236}">
-                <a16:creationId xmlns:a16="http://schemas.microsoft.com/office/drawing/2014/main" id="{60CE5E5E-1284-49C3-BFAA-5F2832765917}"/>
+                <a16:creationId xmlns:a16="http://schemas.microsoft.com/office/drawing/2014/main" id="{446DD717-5438-43D3-A583-3E6520FC0BD5}"/>
               </a:ext>
             </a:extLst>
           </p:cNvPr>
@@ -9007,7 +9007,7 @@
           <p:cNvPr id="2" name="text-69">
             <a:extLst xmlns:a="http://schemas.openxmlformats.org/drawingml/2006/main">
               <a:ext uri="{FF2B5EF4-FFF2-40B4-BE49-F238E27FC236}">
-                <a16:creationId xmlns:a16="http://schemas.microsoft.com/office/drawing/2014/main" id="{3560E732-EC49-4233-B29B-28A817454D3F}"/>
+                <a16:creationId xmlns:a16="http://schemas.microsoft.com/office/drawing/2014/main" id="{FD717DD2-6798-483F-AB9F-3B7CF35540EF}"/>
               </a:ext>
             </a:extLst>
           </p:cNvPr>
@@ -9064,7 +9064,7 @@
           <p:cNvPr id="3" name="">
             <a:extLst xmlns:a="http://schemas.openxmlformats.org/drawingml/2006/main">
               <a:ext uri="{FF2B5EF4-FFF2-40B4-BE49-F238E27FC236}">
-                <a16:creationId xmlns:a16="http://schemas.microsoft.com/office/drawing/2014/main" id="{6830A928-D97C-42EB-AA1A-7501C86E47C5}"/>
+                <a16:creationId xmlns:a16="http://schemas.microsoft.com/office/drawing/2014/main" id="{6CCDCC7E-9C12-49F8-8C5E-170A8BA9E8FD}"/>
               </a:ext>
             </a:extLst>
           </p:cNvPr>
@@ -9094,7 +9094,7 @@
           <p:cNvPr id="4" name="text-70">
             <a:extLst xmlns:a="http://schemas.openxmlformats.org/drawingml/2006/main">
               <a:ext uri="{FF2B5EF4-FFF2-40B4-BE49-F238E27FC236}">
-                <a16:creationId xmlns:a16="http://schemas.microsoft.com/office/drawing/2014/main" id="{AA623BD1-D30A-4F59-AD5E-AB091319B59D}"/>
+                <a16:creationId xmlns:a16="http://schemas.microsoft.com/office/drawing/2014/main" id="{3BDD2F1C-7169-481D-B9B2-2EBCA9F4D78C}"/>
               </a:ext>
             </a:extLst>
           </p:cNvPr>
@@ -9151,7 +9151,7 @@
           <p:cNvPr id="5" name="text-71">
             <a:extLst xmlns:a="http://schemas.openxmlformats.org/drawingml/2006/main">
               <a:ext uri="{FF2B5EF4-FFF2-40B4-BE49-F238E27FC236}">
-                <a16:creationId xmlns:a16="http://schemas.microsoft.com/office/drawing/2014/main" id="{228A3FF0-2A03-42A5-AAFB-B80C307C304E}"/>
+                <a16:creationId xmlns:a16="http://schemas.microsoft.com/office/drawing/2014/main" id="{D90BEED2-DE5F-4F76-B2D8-E9E24AC678A3}"/>
               </a:ext>
             </a:extLst>
           </p:cNvPr>
@@ -9500,7 +9500,7 @@
           <p:cNvPr id="7" name="text-72">
             <a:extLst xmlns:a="http://schemas.openxmlformats.org/drawingml/2006/main">
               <a:ext uri="{FF2B5EF4-FFF2-40B4-BE49-F238E27FC236}">
-                <a16:creationId xmlns:a16="http://schemas.microsoft.com/office/drawing/2014/main" id="{FDE35FA3-06D5-40DD-BC27-0AC16C1CCBF5}"/>
+                <a16:creationId xmlns:a16="http://schemas.microsoft.com/office/drawing/2014/main" id="{328B0225-DFFD-4F76-95C6-F97DBCF6BCE4}"/>
               </a:ext>
             </a:extLst>
           </p:cNvPr>
@@ -9557,7 +9557,7 @@
           <p:cNvPr id="8" name="text-73">
             <a:extLst xmlns:a="http://schemas.openxmlformats.org/drawingml/2006/main">
               <a:ext uri="{FF2B5EF4-FFF2-40B4-BE49-F238E27FC236}">
-                <a16:creationId xmlns:a16="http://schemas.microsoft.com/office/drawing/2014/main" id="{A339649D-F531-4CCB-8C9D-EDE63A897BB7}"/>
+                <a16:creationId xmlns:a16="http://schemas.microsoft.com/office/drawing/2014/main" id="{1B5EAC3B-9F42-4C79-B64E-3D58280B3E3B}"/>
               </a:ext>
             </a:extLst>
           </p:cNvPr>
@@ -9614,7 +9614,7 @@
           <p:cNvPr id="9" name="text-74">
             <a:extLst xmlns:a="http://schemas.openxmlformats.org/drawingml/2006/main">
               <a:ext uri="{FF2B5EF4-FFF2-40B4-BE49-F238E27FC236}">
-                <a16:creationId xmlns:a16="http://schemas.microsoft.com/office/drawing/2014/main" id="{CEC1B423-5ABB-4941-8EF2-1C2F06E02594}"/>
+                <a16:creationId xmlns:a16="http://schemas.microsoft.com/office/drawing/2014/main" id="{6902AECB-391F-465E-9334-2F2E0CEE997D}"/>
               </a:ext>
             </a:extLst>
           </p:cNvPr>
@@ -9669,7 +9669,7 @@
     </p:spTree>
     <p:extLst>
       <p:ext uri="{BB962C8B-B14F-4D97-AF65-F5344CB8AC3E}">
-        <p14:creationId xmlns:p14="http://schemas.microsoft.com/office/powerpoint/2010/main" val="1362784554"/>
+        <p14:creationId xmlns:p14="http://schemas.microsoft.com/office/powerpoint/2010/main" val="2009366579"/>
       </p:ext>
     </p:extLst>
   </p:cSld>

</xml_diff>

<commit_message>
Put every submission artifact one click from the cover
Add verified external hyperlinks for the source repository, public web demo, and demo video to the first slide and matching PDF annotations.

Constraint: Preserve the current 10-slide layout and team details

Confidence: high

Scope-risk: narrow

Tested: PPTX finalizer and package integrity, full-size cover render, three external PPTX relationships, three PDF URI annotations, 10-page PDF

Not-tested: PowerPoint desktop
</commit_message>
<xml_diff>
--- a/slides/ChainLens-BLOCK-AI26-Proposal.pptx
+++ b/slides/ChainLens-BLOCK-AI26-Proposal.pptx
@@ -2,22 +2,22 @@
 <file path=ppt/presentation.xml><?xml version="1.0" encoding="utf-8"?>
 <p:presentation xmlns:p="http://schemas.openxmlformats.org/presentationml/2006/main">
   <p:sldMasterIdLst>
-    <p:sldMasterId xmlns:r="http://schemas.openxmlformats.org/officeDocument/2006/relationships" id="2147483648" r:id="R3d0f792305a84604"/>
+    <p:sldMasterId xmlns:r="http://schemas.openxmlformats.org/officeDocument/2006/relationships" id="2147483648" r:id="R7a6140a8dc9746e9"/>
   </p:sldMasterIdLst>
   <p:notesMasterIdLst>
-    <p:notesMasterId xmlns:r="http://schemas.openxmlformats.org/officeDocument/2006/relationships" r:id="R66dc3f46c0004fc5"/>
+    <p:notesMasterId xmlns:r="http://schemas.openxmlformats.org/officeDocument/2006/relationships" r:id="Ra113519b115140fd"/>
   </p:notesMasterIdLst>
   <p:sldIdLst>
-    <p:sldId xmlns:r="http://schemas.openxmlformats.org/officeDocument/2006/relationships" id="256" r:id="R92b67e13bebd40f0"/>
-    <p:sldId xmlns:r="http://schemas.openxmlformats.org/officeDocument/2006/relationships" id="257" r:id="R7ff52a8082444207"/>
-    <p:sldId xmlns:r="http://schemas.openxmlformats.org/officeDocument/2006/relationships" id="258" r:id="R31cd1cb8907f4e7a"/>
-    <p:sldId xmlns:r="http://schemas.openxmlformats.org/officeDocument/2006/relationships" id="259" r:id="Rdae29cebe5ff48f9"/>
-    <p:sldId xmlns:r="http://schemas.openxmlformats.org/officeDocument/2006/relationships" id="260" r:id="R1a9d877d358c45b0"/>
-    <p:sldId xmlns:r="http://schemas.openxmlformats.org/officeDocument/2006/relationships" id="261" r:id="R72bf074124b04a1a"/>
-    <p:sldId xmlns:r="http://schemas.openxmlformats.org/officeDocument/2006/relationships" id="262" r:id="Rf6d7aaf2a3fa4e6e"/>
-    <p:sldId xmlns:r="http://schemas.openxmlformats.org/officeDocument/2006/relationships" id="263" r:id="Rba56d1c5c4524f46"/>
-    <p:sldId xmlns:r="http://schemas.openxmlformats.org/officeDocument/2006/relationships" id="264" r:id="R51fbfced3a204ffc"/>
-    <p:sldId xmlns:r="http://schemas.openxmlformats.org/officeDocument/2006/relationships" id="265" r:id="R2dd2a22aa0734b1a"/>
+    <p:sldId xmlns:r="http://schemas.openxmlformats.org/officeDocument/2006/relationships" id="256" r:id="R2cd5741d69b0420f"/>
+    <p:sldId xmlns:r="http://schemas.openxmlformats.org/officeDocument/2006/relationships" id="257" r:id="R8343bd750b684016"/>
+    <p:sldId xmlns:r="http://schemas.openxmlformats.org/officeDocument/2006/relationships" id="258" r:id="Rea3c5b7d1631423d"/>
+    <p:sldId xmlns:r="http://schemas.openxmlformats.org/officeDocument/2006/relationships" id="259" r:id="R74941942c07c4575"/>
+    <p:sldId xmlns:r="http://schemas.openxmlformats.org/officeDocument/2006/relationships" id="260" r:id="R32e7b5b2608649d5"/>
+    <p:sldId xmlns:r="http://schemas.openxmlformats.org/officeDocument/2006/relationships" id="261" r:id="R177c5a630e2347e6"/>
+    <p:sldId xmlns:r="http://schemas.openxmlformats.org/officeDocument/2006/relationships" id="262" r:id="R277eb6e00d184fcc"/>
+    <p:sldId xmlns:r="http://schemas.openxmlformats.org/officeDocument/2006/relationships" id="263" r:id="R81bb6fc26afe4989"/>
+    <p:sldId xmlns:r="http://schemas.openxmlformats.org/officeDocument/2006/relationships" id="264" r:id="Rb7d437dcb7354b59"/>
+    <p:sldId xmlns:r="http://schemas.openxmlformats.org/officeDocument/2006/relationships" id="265" r:id="Rf721a61417744731"/>
   </p:sldIdLst>
   <p:sldSz cx="12192000" cy="6858000"/>
   <p:notesSz cx="6858000" cy="9144000"/>
@@ -1149,7 +1149,7 @@
   </p:cSld>
   <p:clrMap bg1="lt1" tx1="dk1" bg2="lt2" tx2="dk2" accent1="accent1" accent2="accent2" accent3="accent3" accent4="accent4" accent5="accent5" accent6="accent6" hlink="hlink" folHlink="folHlink"/>
   <p:sldLayoutIdLst>
-    <p:sldLayoutId xmlns:r="http://schemas.openxmlformats.org/officeDocument/2006/relationships" id="2147483649" r:id="R2e006090e9f74b21"/>
+    <p:sldLayoutId xmlns:r="http://schemas.openxmlformats.org/officeDocument/2006/relationships" id="2147483649" r:id="Rf6f4e111c586471c"/>
   </p:sldLayoutIdLst>
   <p:txStyles>
     <p:titleStyle>
@@ -1697,10 +1697,10 @@
       </p:grpSpPr>
       <p:sp>
         <p:nvSpPr>
-          <p:cNvPr id="7" name="text-1">
+          <p:cNvPr id="10" name="text-1">
             <a:extLst xmlns:a="http://schemas.openxmlformats.org/drawingml/2006/main">
               <a:ext uri="{FF2B5EF4-FFF2-40B4-BE49-F238E27FC236}">
-                <a16:creationId xmlns:a16="http://schemas.microsoft.com/office/drawing/2014/main" id="{8938F0B8-C3DF-456F-90D0-25A26091DCCA}"/>
+                <a16:creationId xmlns:a16="http://schemas.microsoft.com/office/drawing/2014/main" id="{B4F26B5B-8CDA-4A26-90C0-13D28FE59A94}"/>
               </a:ext>
             </a:extLst>
           </p:cNvPr>
@@ -1757,7 +1757,7 @@
           <p:cNvPr id="2" name="text-2">
             <a:extLst xmlns:a="http://schemas.openxmlformats.org/drawingml/2006/main">
               <a:ext uri="{FF2B5EF4-FFF2-40B4-BE49-F238E27FC236}">
-                <a16:creationId xmlns:a16="http://schemas.microsoft.com/office/drawing/2014/main" id="{D1E15BB5-F690-4FE8-9769-FF274C611F9A}"/>
+                <a16:creationId xmlns:a16="http://schemas.microsoft.com/office/drawing/2014/main" id="{83CE3998-9614-4753-B7D4-ED81F8324D02}"/>
               </a:ext>
             </a:extLst>
           </p:cNvPr>
@@ -1814,7 +1814,7 @@
           <p:cNvPr id="3" name="text-3">
             <a:extLst xmlns:a="http://schemas.openxmlformats.org/drawingml/2006/main">
               <a:ext uri="{FF2B5EF4-FFF2-40B4-BE49-F238E27FC236}">
-                <a16:creationId xmlns:a16="http://schemas.microsoft.com/office/drawing/2014/main" id="{8CBCE219-4AEF-40FC-83BC-2D15FC31635E}"/>
+                <a16:creationId xmlns:a16="http://schemas.microsoft.com/office/drawing/2014/main" id="{B62B088C-7B95-4803-B668-7FFD21AD2907}"/>
               </a:ext>
             </a:extLst>
           </p:cNvPr>
@@ -1871,7 +1871,7 @@
           <p:cNvPr id="4" name="text-4">
             <a:extLst xmlns:a="http://schemas.openxmlformats.org/drawingml/2006/main">
               <a:ext uri="{FF2B5EF4-FFF2-40B4-BE49-F238E27FC236}">
-                <a16:creationId xmlns:a16="http://schemas.microsoft.com/office/drawing/2014/main" id="{52C14827-70AE-444A-BC83-152EE3D6987C}"/>
+                <a16:creationId xmlns:a16="http://schemas.microsoft.com/office/drawing/2014/main" id="{3FDA3607-7267-4B16-A342-062F33FF33C6}"/>
               </a:ext>
             </a:extLst>
           </p:cNvPr>
@@ -1951,7 +1951,7 @@
           <p:cNvPr id="5" name="text-5">
             <a:extLst xmlns:a="http://schemas.openxmlformats.org/drawingml/2006/main">
               <a:ext uri="{FF2B5EF4-FFF2-40B4-BE49-F238E27FC236}">
-                <a16:creationId xmlns:a16="http://schemas.microsoft.com/office/drawing/2014/main" id="{A5B15234-DA69-4768-A56D-4B6A1F325E82}"/>
+                <a16:creationId xmlns:a16="http://schemas.microsoft.com/office/drawing/2014/main" id="{16D57244-9628-49BA-9E23-E42158DCB8DE}"/>
               </a:ext>
             </a:extLst>
           </p:cNvPr>
@@ -1962,8 +1962,8 @@
         </p:nvSpPr>
         <p:spPr>
           <a:xfrm xmlns:a="http://schemas.openxmlformats.org/drawingml/2006/main">
-            <a:off x="657225" y="5772150"/>
-            <a:ext cx="10668000" cy="304800"/>
+            <a:off x="657225" y="5048250"/>
+            <a:ext cx="10668000" cy="190500"/>
           </a:xfrm>
           <a:prstGeom xmlns:a="http://schemas.openxmlformats.org/drawingml/2006/main" prst="rect">
             <a:avLst/>
@@ -1980,7 +1980,7 @@
           <a:lstStyle xmlns:a="http://schemas.openxmlformats.org/drawingml/2006/main"/>
           <a:p xmlns:a="http://schemas.openxmlformats.org/drawingml/2006/main">
             <a:pPr>
-              <a:defRPr sz="1575" b="0">
+              <a:defRPr sz="1125" b="0">
                 <a:solidFill>
                   <a:srgbClr val="B8D3FF"/>
                 </a:solidFill>
@@ -1990,15 +1990,21 @@
               </a:defRPr>
             </a:pPr>
             <a:r>
-              <a:rPr sz="1575" b="0">
+              <a:rPr b="1">
                 <a:solidFill>
                   <a:srgbClr val="B8D3FF"/>
                 </a:solidFill>
-                <a:latin typeface="Apple SD Gothic Neo"/>
-                <a:ea typeface="Apple SD Gothic Neo"/>
-                <a:cs typeface="Apple SD Gothic Neo"/>
-              </a:rPr>
-              <a:t>Chrome MV3 확장 · Ethereum 거래 해석 · AI API 설명 경로</a:t>
+              </a:rPr>
+              <a:t>GitHub  </a:t>
+            </a:r>
+            <a:r>
+              <a:rPr u="sng">
+                <a:solidFill>
+                  <a:srgbClr val="B8D3FF"/>
+                </a:solidFill>
+                <a:hlinkClick xmlns:r="http://schemas.openxmlformats.org/officeDocument/2006/relationships" r:id="R9706ee4440254d07"/>
+              </a:rPr>
+              <a:t>github.com/diveyreadytodive-star/chainlens</a:t>
             </a:r>
           </a:p>
         </p:txBody>
@@ -2008,7 +2014,7 @@
           <p:cNvPr id="6" name="text-6">
             <a:extLst xmlns:a="http://schemas.openxmlformats.org/drawingml/2006/main">
               <a:ext uri="{FF2B5EF4-FFF2-40B4-BE49-F238E27FC236}">
-                <a16:creationId xmlns:a16="http://schemas.microsoft.com/office/drawing/2014/main" id="{639CD528-DCE9-4D99-BB48-75DA7BA05762}"/>
+                <a16:creationId xmlns:a16="http://schemas.microsoft.com/office/drawing/2014/main" id="{E83F43E2-C4FB-42C5-AAF9-0D292393089B}"/>
               </a:ext>
             </a:extLst>
           </p:cNvPr>
@@ -2019,8 +2025,8 @@
         </p:nvSpPr>
         <p:spPr>
           <a:xfrm xmlns:a="http://schemas.openxmlformats.org/drawingml/2006/main">
-            <a:off x="657225" y="6181725"/>
-            <a:ext cx="10668000" cy="238125"/>
+            <a:off x="657225" y="5267325"/>
+            <a:ext cx="10668000" cy="190500"/>
           </a:xfrm>
           <a:prstGeom xmlns:a="http://schemas.openxmlformats.org/drawingml/2006/main" prst="rect">
             <a:avLst/>
@@ -2037,6 +2043,189 @@
           <a:lstStyle xmlns:a="http://schemas.openxmlformats.org/drawingml/2006/main"/>
           <a:p xmlns:a="http://schemas.openxmlformats.org/drawingml/2006/main">
             <a:pPr>
+              <a:defRPr sz="1125" b="0">
+                <a:solidFill>
+                  <a:srgbClr val="B8D3FF"/>
+                </a:solidFill>
+                <a:latin typeface="Apple SD Gothic Neo"/>
+                <a:ea typeface="Apple SD Gothic Neo"/>
+                <a:cs typeface="Apple SD Gothic Neo"/>
+              </a:defRPr>
+            </a:pPr>
+            <a:r>
+              <a:rPr b="1">
+                <a:solidFill>
+                  <a:srgbClr val="B8D3FF"/>
+                </a:solidFill>
+              </a:rPr>
+              <a:t>Web Demo  </a:t>
+            </a:r>
+            <a:r>
+              <a:rPr u="sng">
+                <a:solidFill>
+                  <a:srgbClr val="B8D3FF"/>
+                </a:solidFill>
+                <a:hlinkClick xmlns:r="http://schemas.openxmlformats.org/officeDocument/2006/relationships" r:id="Rc762888116eb445b"/>
+              </a:rPr>
+              <a:t>chainlens-lyart.vercel.app</a:t>
+            </a:r>
+          </a:p>
+        </p:txBody>
+      </p:sp>
+      <p:sp>
+        <p:nvSpPr>
+          <p:cNvPr id="7" name="text-7">
+            <a:extLst xmlns:a="http://schemas.openxmlformats.org/drawingml/2006/main">
+              <a:ext uri="{FF2B5EF4-FFF2-40B4-BE49-F238E27FC236}">
+                <a16:creationId xmlns:a16="http://schemas.microsoft.com/office/drawing/2014/main" id="{38A2958A-A838-4BDF-9F00-A0CE04007B49}"/>
+              </a:ext>
+            </a:extLst>
+          </p:cNvPr>
+          <p:cNvSpPr>
+            <a:spLocks xmlns:a="http://schemas.openxmlformats.org/drawingml/2006/main" noGrp="1"/>
+          </p:cNvSpPr>
+          <p:nvPr/>
+        </p:nvSpPr>
+        <p:spPr>
+          <a:xfrm xmlns:a="http://schemas.openxmlformats.org/drawingml/2006/main">
+            <a:off x="657225" y="5486400"/>
+            <a:ext cx="10668000" cy="190500"/>
+          </a:xfrm>
+          <a:prstGeom xmlns:a="http://schemas.openxmlformats.org/drawingml/2006/main" prst="rect">
+            <a:avLst/>
+          </a:prstGeom>
+          <a:noFill xmlns:a="http://schemas.openxmlformats.org/drawingml/2006/main"/>
+          <a:ln xmlns:a="http://schemas.openxmlformats.org/drawingml/2006/main" w="0">
+            <a:noFill/>
+          </a:ln>
+        </p:spPr>
+        <p:txBody>
+          <a:bodyPr xmlns:a="http://schemas.openxmlformats.org/drawingml/2006/main" wrap="square" lIns="0" tIns="0" rIns="0" bIns="0" anchor="t">
+            <a:noAutofit/>
+          </a:bodyPr>
+          <a:lstStyle xmlns:a="http://schemas.openxmlformats.org/drawingml/2006/main"/>
+          <a:p xmlns:a="http://schemas.openxmlformats.org/drawingml/2006/main">
+            <a:pPr>
+              <a:defRPr sz="1125" b="0">
+                <a:solidFill>
+                  <a:srgbClr val="B8D3FF"/>
+                </a:solidFill>
+                <a:latin typeface="Apple SD Gothic Neo"/>
+                <a:ea typeface="Apple SD Gothic Neo"/>
+                <a:cs typeface="Apple SD Gothic Neo"/>
+              </a:defRPr>
+            </a:pPr>
+            <a:r>
+              <a:rPr b="1">
+                <a:solidFill>
+                  <a:srgbClr val="B8D3FF"/>
+                </a:solidFill>
+              </a:rPr>
+              <a:t>Demo Video  </a:t>
+            </a:r>
+            <a:r>
+              <a:rPr u="sng">
+                <a:solidFill>
+                  <a:srgbClr val="B8D3FF"/>
+                </a:solidFill>
+                <a:hlinkClick xmlns:r="http://schemas.openxmlformats.org/officeDocument/2006/relationships" r:id="R740352a845c54c3b"/>
+              </a:rPr>
+              <a:t>youtu.be/6VMEIPlQack</a:t>
+            </a:r>
+          </a:p>
+        </p:txBody>
+      </p:sp>
+      <p:sp>
+        <p:nvSpPr>
+          <p:cNvPr id="8" name="text-8">
+            <a:extLst xmlns:a="http://schemas.openxmlformats.org/drawingml/2006/main">
+              <a:ext uri="{FF2B5EF4-FFF2-40B4-BE49-F238E27FC236}">
+                <a16:creationId xmlns:a16="http://schemas.microsoft.com/office/drawing/2014/main" id="{57D13FCE-D0E5-414E-AF4B-BB2A0374FBB9}"/>
+              </a:ext>
+            </a:extLst>
+          </p:cNvPr>
+          <p:cNvSpPr>
+            <a:spLocks xmlns:a="http://schemas.openxmlformats.org/drawingml/2006/main" noGrp="1"/>
+          </p:cNvSpPr>
+          <p:nvPr/>
+        </p:nvSpPr>
+        <p:spPr>
+          <a:xfrm xmlns:a="http://schemas.openxmlformats.org/drawingml/2006/main">
+            <a:off x="657225" y="5772150"/>
+            <a:ext cx="10668000" cy="304800"/>
+          </a:xfrm>
+          <a:prstGeom xmlns:a="http://schemas.openxmlformats.org/drawingml/2006/main" prst="rect">
+            <a:avLst/>
+          </a:prstGeom>
+          <a:noFill xmlns:a="http://schemas.openxmlformats.org/drawingml/2006/main"/>
+          <a:ln xmlns:a="http://schemas.openxmlformats.org/drawingml/2006/main" w="0">
+            <a:noFill/>
+          </a:ln>
+        </p:spPr>
+        <p:txBody>
+          <a:bodyPr xmlns:a="http://schemas.openxmlformats.org/drawingml/2006/main" wrap="square" lIns="0" tIns="0" rIns="0" bIns="0" anchor="t">
+            <a:noAutofit/>
+          </a:bodyPr>
+          <a:lstStyle xmlns:a="http://schemas.openxmlformats.org/drawingml/2006/main"/>
+          <a:p xmlns:a="http://schemas.openxmlformats.org/drawingml/2006/main">
+            <a:pPr>
+              <a:defRPr sz="1575" b="0">
+                <a:solidFill>
+                  <a:srgbClr val="B8D3FF"/>
+                </a:solidFill>
+                <a:latin typeface="Apple SD Gothic Neo"/>
+                <a:ea typeface="Apple SD Gothic Neo"/>
+                <a:cs typeface="Apple SD Gothic Neo"/>
+              </a:defRPr>
+            </a:pPr>
+            <a:r>
+              <a:rPr sz="1575" b="0">
+                <a:solidFill>
+                  <a:srgbClr val="B8D3FF"/>
+                </a:solidFill>
+                <a:latin typeface="Apple SD Gothic Neo"/>
+                <a:ea typeface="Apple SD Gothic Neo"/>
+                <a:cs typeface="Apple SD Gothic Neo"/>
+              </a:rPr>
+              <a:t>Chrome MV3 확장 · Ethereum 거래 해석 · AI API 설명 경로</a:t>
+            </a:r>
+          </a:p>
+        </p:txBody>
+      </p:sp>
+      <p:sp>
+        <p:nvSpPr>
+          <p:cNvPr id="9" name="text-9">
+            <a:extLst xmlns:a="http://schemas.openxmlformats.org/drawingml/2006/main">
+              <a:ext uri="{FF2B5EF4-FFF2-40B4-BE49-F238E27FC236}">
+                <a16:creationId xmlns:a16="http://schemas.microsoft.com/office/drawing/2014/main" id="{59702689-FDDE-40C0-BDAD-A8266E1177C2}"/>
+              </a:ext>
+            </a:extLst>
+          </p:cNvPr>
+          <p:cNvSpPr>
+            <a:spLocks xmlns:a="http://schemas.openxmlformats.org/drawingml/2006/main" noGrp="1"/>
+          </p:cNvSpPr>
+          <p:nvPr/>
+        </p:nvSpPr>
+        <p:spPr>
+          <a:xfrm xmlns:a="http://schemas.openxmlformats.org/drawingml/2006/main">
+            <a:off x="657225" y="6181725"/>
+            <a:ext cx="10668000" cy="238125"/>
+          </a:xfrm>
+          <a:prstGeom xmlns:a="http://schemas.openxmlformats.org/drawingml/2006/main" prst="rect">
+            <a:avLst/>
+          </a:prstGeom>
+          <a:noFill xmlns:a="http://schemas.openxmlformats.org/drawingml/2006/main"/>
+          <a:ln xmlns:a="http://schemas.openxmlformats.org/drawingml/2006/main" w="0">
+            <a:noFill/>
+          </a:ln>
+        </p:spPr>
+        <p:txBody>
+          <a:bodyPr xmlns:a="http://schemas.openxmlformats.org/drawingml/2006/main" wrap="square" lIns="0" tIns="0" rIns="0" bIns="0" anchor="t">
+            <a:noAutofit/>
+          </a:bodyPr>
+          <a:lstStyle xmlns:a="http://schemas.openxmlformats.org/drawingml/2006/main"/>
+          <a:p xmlns:a="http://schemas.openxmlformats.org/drawingml/2006/main">
+            <a:pPr>
               <a:defRPr sz="1425" b="0">
                 <a:solidFill>
                   <a:srgbClr val="B8D3FF"/>
@@ -2063,7 +2252,7 @@
     </p:spTree>
     <p:extLst>
       <p:ext uri="{BB962C8B-B14F-4D97-AF65-F5344CB8AC3E}">
-        <p14:creationId xmlns:p14="http://schemas.microsoft.com/office/powerpoint/2010/main" val="165721257"/>
+        <p14:creationId xmlns:p14="http://schemas.microsoft.com/office/powerpoint/2010/main" val="570100297"/>
       </p:ext>
     </p:extLst>
   </p:cSld>
@@ -2091,10 +2280,10 @@
       </p:grpSpPr>
       <p:sp>
         <p:nvSpPr>
-          <p:cNvPr id="10" name="text-75">
+          <p:cNvPr id="10" name="text-78">
             <a:extLst xmlns:a="http://schemas.openxmlformats.org/drawingml/2006/main">
               <a:ext uri="{FF2B5EF4-FFF2-40B4-BE49-F238E27FC236}">
-                <a16:creationId xmlns:a16="http://schemas.microsoft.com/office/drawing/2014/main" id="{C998D3D7-F833-4503-B8AC-6C954C942361}"/>
+                <a16:creationId xmlns:a16="http://schemas.microsoft.com/office/drawing/2014/main" id="{146C68D1-94A2-4222-A82C-D6430909F143}"/>
               </a:ext>
             </a:extLst>
           </p:cNvPr>
@@ -2148,10 +2337,10 @@
       </p:sp>
       <p:sp>
         <p:nvSpPr>
-          <p:cNvPr id="2" name="text-76">
+          <p:cNvPr id="2" name="text-79">
             <a:extLst xmlns:a="http://schemas.openxmlformats.org/drawingml/2006/main">
               <a:ext uri="{FF2B5EF4-FFF2-40B4-BE49-F238E27FC236}">
-                <a16:creationId xmlns:a16="http://schemas.microsoft.com/office/drawing/2014/main" id="{4E511964-7463-41C6-A3D8-2F270247E743}"/>
+                <a16:creationId xmlns:a16="http://schemas.microsoft.com/office/drawing/2014/main" id="{A1464F35-D033-4901-AA6C-BFF5E4AD0255}"/>
               </a:ext>
             </a:extLst>
           </p:cNvPr>
@@ -2208,7 +2397,7 @@
           <p:cNvPr id="3" name="">
             <a:extLst xmlns:a="http://schemas.openxmlformats.org/drawingml/2006/main">
               <a:ext uri="{FF2B5EF4-FFF2-40B4-BE49-F238E27FC236}">
-                <a16:creationId xmlns:a16="http://schemas.microsoft.com/office/drawing/2014/main" id="{9274261B-73F2-490B-9805-F6CE6A188A01}"/>
+                <a16:creationId xmlns:a16="http://schemas.microsoft.com/office/drawing/2014/main" id="{7DFB586D-BACD-40A7-8E65-DFAECCE3DD7D}"/>
               </a:ext>
             </a:extLst>
           </p:cNvPr>
@@ -2235,10 +2424,10 @@
       </p:sp>
       <p:sp>
         <p:nvSpPr>
-          <p:cNvPr id="4" name="text-77">
+          <p:cNvPr id="4" name="text-80">
             <a:extLst xmlns:a="http://schemas.openxmlformats.org/drawingml/2006/main">
               <a:ext uri="{FF2B5EF4-FFF2-40B4-BE49-F238E27FC236}">
-                <a16:creationId xmlns:a16="http://schemas.microsoft.com/office/drawing/2014/main" id="{8A6E9B18-6178-4741-995F-7C7EF81819A0}"/>
+                <a16:creationId xmlns:a16="http://schemas.microsoft.com/office/drawing/2014/main" id="{5F816570-5F37-4211-B18E-A45739AA73C3}"/>
               </a:ext>
             </a:extLst>
           </p:cNvPr>
@@ -2292,10 +2481,10 @@
       </p:sp>
       <p:sp>
         <p:nvSpPr>
-          <p:cNvPr id="5" name="text-78">
+          <p:cNvPr id="5" name="text-81">
             <a:extLst xmlns:a="http://schemas.openxmlformats.org/drawingml/2006/main">
               <a:ext uri="{FF2B5EF4-FFF2-40B4-BE49-F238E27FC236}">
-                <a16:creationId xmlns:a16="http://schemas.microsoft.com/office/drawing/2014/main" id="{B040BDDE-2290-444C-B03F-1749CA20B770}"/>
+                <a16:creationId xmlns:a16="http://schemas.microsoft.com/office/drawing/2014/main" id="{3608BFDE-8CC1-4DF7-B64F-A26D2BA451EF}"/>
               </a:ext>
             </a:extLst>
           </p:cNvPr>
@@ -2749,10 +2938,10 @@
       </p:graphicFrame>
       <p:sp>
         <p:nvSpPr>
-          <p:cNvPr id="7" name="text-79">
+          <p:cNvPr id="7" name="text-82">
             <a:extLst xmlns:a="http://schemas.openxmlformats.org/drawingml/2006/main">
               <a:ext uri="{FF2B5EF4-FFF2-40B4-BE49-F238E27FC236}">
-                <a16:creationId xmlns:a16="http://schemas.microsoft.com/office/drawing/2014/main" id="{D62A1383-C51D-48C2-9046-8DABF9F96934}"/>
+                <a16:creationId xmlns:a16="http://schemas.microsoft.com/office/drawing/2014/main" id="{5EE90F4D-168A-43E4-9D66-8C036DED9052}"/>
               </a:ext>
             </a:extLst>
           </p:cNvPr>
@@ -2806,10 +2995,10 @@
       </p:sp>
       <p:sp>
         <p:nvSpPr>
-          <p:cNvPr id="8" name="text-80">
+          <p:cNvPr id="8" name="text-83">
             <a:extLst xmlns:a="http://schemas.openxmlformats.org/drawingml/2006/main">
               <a:ext uri="{FF2B5EF4-FFF2-40B4-BE49-F238E27FC236}">
-                <a16:creationId xmlns:a16="http://schemas.microsoft.com/office/drawing/2014/main" id="{4B1A5F9F-71C8-4278-8DAA-054F7363A7C0}"/>
+                <a16:creationId xmlns:a16="http://schemas.microsoft.com/office/drawing/2014/main" id="{7ACDB7BA-D896-4FB1-BCC5-950ADBAFE572}"/>
               </a:ext>
             </a:extLst>
           </p:cNvPr>
@@ -2886,10 +3075,10 @@
       </p:sp>
       <p:sp>
         <p:nvSpPr>
-          <p:cNvPr id="9" name="text-81">
+          <p:cNvPr id="9" name="text-84">
             <a:extLst xmlns:a="http://schemas.openxmlformats.org/drawingml/2006/main">
               <a:ext uri="{FF2B5EF4-FFF2-40B4-BE49-F238E27FC236}">
-                <a16:creationId xmlns:a16="http://schemas.microsoft.com/office/drawing/2014/main" id="{1882BA75-6A8E-4036-BDAE-52244ACA2196}"/>
+                <a16:creationId xmlns:a16="http://schemas.microsoft.com/office/drawing/2014/main" id="{4FD5367B-A1D8-4674-8944-9629AF6E8B07}"/>
               </a:ext>
             </a:extLst>
           </p:cNvPr>
@@ -2944,7 +3133,7 @@
     </p:spTree>
     <p:extLst>
       <p:ext uri="{BB962C8B-B14F-4D97-AF65-F5344CB8AC3E}">
-        <p14:creationId xmlns:p14="http://schemas.microsoft.com/office/powerpoint/2010/main" val="1944919626"/>
+        <p14:creationId xmlns:p14="http://schemas.microsoft.com/office/powerpoint/2010/main" val="271735394"/>
       </p:ext>
     </p:extLst>
   </p:cSld>
@@ -2972,10 +3161,10 @@
       </p:grpSpPr>
       <p:sp>
         <p:nvSpPr>
-          <p:cNvPr id="11" name="text-7">
+          <p:cNvPr id="11" name="text-10">
             <a:extLst xmlns:a="http://schemas.openxmlformats.org/drawingml/2006/main">
               <a:ext uri="{FF2B5EF4-FFF2-40B4-BE49-F238E27FC236}">
-                <a16:creationId xmlns:a16="http://schemas.microsoft.com/office/drawing/2014/main" id="{14D4E2FA-CCDB-4EBF-8A6B-235C85C58082}"/>
+                <a16:creationId xmlns:a16="http://schemas.microsoft.com/office/drawing/2014/main" id="{7FE41070-20AC-4F73-8DF9-3B1C9F903880}"/>
               </a:ext>
             </a:extLst>
           </p:cNvPr>
@@ -3029,10 +3218,10 @@
       </p:sp>
       <p:sp>
         <p:nvSpPr>
-          <p:cNvPr id="2" name="text-8">
+          <p:cNvPr id="2" name="text-11">
             <a:extLst xmlns:a="http://schemas.openxmlformats.org/drawingml/2006/main">
               <a:ext uri="{FF2B5EF4-FFF2-40B4-BE49-F238E27FC236}">
-                <a16:creationId xmlns:a16="http://schemas.microsoft.com/office/drawing/2014/main" id="{56A19275-623A-4C58-B20F-4186F3FB5A13}"/>
+                <a16:creationId xmlns:a16="http://schemas.microsoft.com/office/drawing/2014/main" id="{6B043941-7115-4EA3-9125-997AE791E8A6}"/>
               </a:ext>
             </a:extLst>
           </p:cNvPr>
@@ -3089,7 +3278,7 @@
           <p:cNvPr id="3" name="">
             <a:extLst xmlns:a="http://schemas.openxmlformats.org/drawingml/2006/main">
               <a:ext uri="{FF2B5EF4-FFF2-40B4-BE49-F238E27FC236}">
-                <a16:creationId xmlns:a16="http://schemas.microsoft.com/office/drawing/2014/main" id="{303C27F6-987E-4D80-995F-34F8988183AE}"/>
+                <a16:creationId xmlns:a16="http://schemas.microsoft.com/office/drawing/2014/main" id="{123E6701-ED50-491D-8B2D-11D9A104BD98}"/>
               </a:ext>
             </a:extLst>
           </p:cNvPr>
@@ -3116,10 +3305,10 @@
       </p:sp>
       <p:sp>
         <p:nvSpPr>
-          <p:cNvPr id="4" name="text-9">
+          <p:cNvPr id="4" name="text-12">
             <a:extLst xmlns:a="http://schemas.openxmlformats.org/drawingml/2006/main">
               <a:ext uri="{FF2B5EF4-FFF2-40B4-BE49-F238E27FC236}">
-                <a16:creationId xmlns:a16="http://schemas.microsoft.com/office/drawing/2014/main" id="{22C3ABD4-E4F6-4351-838F-7F32D15A1BDB}"/>
+                <a16:creationId xmlns:a16="http://schemas.microsoft.com/office/drawing/2014/main" id="{99180041-541B-408F-B465-906026E3008A}"/>
               </a:ext>
             </a:extLst>
           </p:cNvPr>
@@ -3173,10 +3362,10 @@
       </p:sp>
       <p:sp>
         <p:nvSpPr>
-          <p:cNvPr id="5" name="text-10">
+          <p:cNvPr id="5" name="text-13">
             <a:extLst xmlns:a="http://schemas.openxmlformats.org/drawingml/2006/main">
               <a:ext uri="{FF2B5EF4-FFF2-40B4-BE49-F238E27FC236}">
-                <a16:creationId xmlns:a16="http://schemas.microsoft.com/office/drawing/2014/main" id="{AE95D44D-E342-4C57-B9AC-2D3850475A6A}"/>
+                <a16:creationId xmlns:a16="http://schemas.microsoft.com/office/drawing/2014/main" id="{BA86A220-3406-468A-A2FA-F544966B6F98}"/>
               </a:ext>
             </a:extLst>
           </p:cNvPr>
@@ -3230,10 +3419,10 @@
       </p:sp>
       <p:sp>
         <p:nvSpPr>
-          <p:cNvPr id="6" name="text-11">
+          <p:cNvPr id="6" name="text-14">
             <a:extLst xmlns:a="http://schemas.openxmlformats.org/drawingml/2006/main">
               <a:ext uri="{FF2B5EF4-FFF2-40B4-BE49-F238E27FC236}">
-                <a16:creationId xmlns:a16="http://schemas.microsoft.com/office/drawing/2014/main" id="{B1A704E5-428C-404F-A70D-5909A23C2028}"/>
+                <a16:creationId xmlns:a16="http://schemas.microsoft.com/office/drawing/2014/main" id="{50E0FDB4-C89F-4E89-B8A9-C01AAAF7DB59}"/>
               </a:ext>
             </a:extLst>
           </p:cNvPr>
@@ -3310,10 +3499,10 @@
       </p:sp>
       <p:sp>
         <p:nvSpPr>
-          <p:cNvPr id="7" name="text-12">
+          <p:cNvPr id="7" name="text-15">
             <a:extLst xmlns:a="http://schemas.openxmlformats.org/drawingml/2006/main">
               <a:ext uri="{FF2B5EF4-FFF2-40B4-BE49-F238E27FC236}">
-                <a16:creationId xmlns:a16="http://schemas.microsoft.com/office/drawing/2014/main" id="{A144AAF3-F44E-49E4-A7A3-DC7DBCC46868}"/>
+                <a16:creationId xmlns:a16="http://schemas.microsoft.com/office/drawing/2014/main" id="{19312CE4-C87E-42D1-8F27-A61B3917CAF0}"/>
               </a:ext>
             </a:extLst>
           </p:cNvPr>
@@ -3628,10 +3817,10 @@
       </p:graphicFrame>
       <p:sp>
         <p:nvSpPr>
-          <p:cNvPr id="9" name="text-13">
+          <p:cNvPr id="9" name="text-16">
             <a:extLst xmlns:a="http://schemas.openxmlformats.org/drawingml/2006/main">
               <a:ext uri="{FF2B5EF4-FFF2-40B4-BE49-F238E27FC236}">
-                <a16:creationId xmlns:a16="http://schemas.microsoft.com/office/drawing/2014/main" id="{B0A633C8-64C2-4388-9298-ACA82BF6E31E}"/>
+                <a16:creationId xmlns:a16="http://schemas.microsoft.com/office/drawing/2014/main" id="{62C31586-AE16-432B-B1D6-7365C171B7FE}"/>
               </a:ext>
             </a:extLst>
           </p:cNvPr>
@@ -3685,10 +3874,10 @@
       </p:sp>
       <p:sp>
         <p:nvSpPr>
-          <p:cNvPr id="10" name="text-14">
+          <p:cNvPr id="10" name="text-17">
             <a:extLst xmlns:a="http://schemas.openxmlformats.org/drawingml/2006/main">
               <a:ext uri="{FF2B5EF4-FFF2-40B4-BE49-F238E27FC236}">
-                <a16:creationId xmlns:a16="http://schemas.microsoft.com/office/drawing/2014/main" id="{E777D291-2694-4153-B5F3-69B80A219BC4}"/>
+                <a16:creationId xmlns:a16="http://schemas.microsoft.com/office/drawing/2014/main" id="{FF29B382-2AEF-4B17-904F-42EB0B8F5B5C}"/>
               </a:ext>
             </a:extLst>
           </p:cNvPr>
@@ -3743,7 +3932,7 @@
     </p:spTree>
     <p:extLst>
       <p:ext uri="{BB962C8B-B14F-4D97-AF65-F5344CB8AC3E}">
-        <p14:creationId xmlns:p14="http://schemas.microsoft.com/office/powerpoint/2010/main" val="979711710"/>
+        <p14:creationId xmlns:p14="http://schemas.microsoft.com/office/powerpoint/2010/main" val="429112385"/>
       </p:ext>
     </p:extLst>
   </p:cSld>
@@ -3771,10 +3960,10 @@
       </p:grpSpPr>
       <p:sp>
         <p:nvSpPr>
-          <p:cNvPr id="10" name="text-15">
+          <p:cNvPr id="10" name="text-18">
             <a:extLst xmlns:a="http://schemas.openxmlformats.org/drawingml/2006/main">
               <a:ext uri="{FF2B5EF4-FFF2-40B4-BE49-F238E27FC236}">
-                <a16:creationId xmlns:a16="http://schemas.microsoft.com/office/drawing/2014/main" id="{26551F94-C085-4A6F-B243-D6222BAADEC7}"/>
+                <a16:creationId xmlns:a16="http://schemas.microsoft.com/office/drawing/2014/main" id="{1E65AB42-8E06-4259-98F3-F4A27B9B8E2D}"/>
               </a:ext>
             </a:extLst>
           </p:cNvPr>
@@ -3828,10 +4017,10 @@
       </p:sp>
       <p:sp>
         <p:nvSpPr>
-          <p:cNvPr id="2" name="text-16">
+          <p:cNvPr id="2" name="text-19">
             <a:extLst xmlns:a="http://schemas.openxmlformats.org/drawingml/2006/main">
               <a:ext uri="{FF2B5EF4-FFF2-40B4-BE49-F238E27FC236}">
-                <a16:creationId xmlns:a16="http://schemas.microsoft.com/office/drawing/2014/main" id="{EBDE4A1D-9E55-4BBD-9D53-3CAB13C114F2}"/>
+                <a16:creationId xmlns:a16="http://schemas.microsoft.com/office/drawing/2014/main" id="{BF13B96F-C4B7-4CBB-9971-B1C407CC848A}"/>
               </a:ext>
             </a:extLst>
           </p:cNvPr>
@@ -3888,7 +4077,7 @@
           <p:cNvPr id="3" name="">
             <a:extLst xmlns:a="http://schemas.openxmlformats.org/drawingml/2006/main">
               <a:ext uri="{FF2B5EF4-FFF2-40B4-BE49-F238E27FC236}">
-                <a16:creationId xmlns:a16="http://schemas.microsoft.com/office/drawing/2014/main" id="{814CF951-464E-4BEF-ADD0-4EC095E32732}"/>
+                <a16:creationId xmlns:a16="http://schemas.microsoft.com/office/drawing/2014/main" id="{B7BC8173-2B32-4599-B1CE-C5968943E4C7}"/>
               </a:ext>
             </a:extLst>
           </p:cNvPr>
@@ -3915,10 +4104,10 @@
       </p:sp>
       <p:sp>
         <p:nvSpPr>
-          <p:cNvPr id="4" name="text-17">
+          <p:cNvPr id="4" name="text-20">
             <a:extLst xmlns:a="http://schemas.openxmlformats.org/drawingml/2006/main">
               <a:ext uri="{FF2B5EF4-FFF2-40B4-BE49-F238E27FC236}">
-                <a16:creationId xmlns:a16="http://schemas.microsoft.com/office/drawing/2014/main" id="{2D77B32D-F1EB-41BB-A911-AADD28C4AE8C}"/>
+                <a16:creationId xmlns:a16="http://schemas.microsoft.com/office/drawing/2014/main" id="{53D58D0D-BFD7-47A7-BC4E-96C187E6BFEF}"/>
               </a:ext>
             </a:extLst>
           </p:cNvPr>
@@ -3972,10 +4161,10 @@
       </p:sp>
       <p:sp>
         <p:nvSpPr>
-          <p:cNvPr id="5" name="text-18">
+          <p:cNvPr id="5" name="text-21">
             <a:extLst xmlns:a="http://schemas.openxmlformats.org/drawingml/2006/main">
               <a:ext uri="{FF2B5EF4-FFF2-40B4-BE49-F238E27FC236}">
-                <a16:creationId xmlns:a16="http://schemas.microsoft.com/office/drawing/2014/main" id="{C5BE1A09-1B0F-4709-8972-72A0AB185B01}"/>
+                <a16:creationId xmlns:a16="http://schemas.microsoft.com/office/drawing/2014/main" id="{7ABE8CFE-C470-4602-A494-D72344440CAA}"/>
               </a:ext>
             </a:extLst>
           </p:cNvPr>
@@ -4267,10 +4456,10 @@
       </p:graphicFrame>
       <p:sp>
         <p:nvSpPr>
-          <p:cNvPr id="7" name="text-19">
+          <p:cNvPr id="7" name="text-22">
             <a:extLst xmlns:a="http://schemas.openxmlformats.org/drawingml/2006/main">
               <a:ext uri="{FF2B5EF4-FFF2-40B4-BE49-F238E27FC236}">
-                <a16:creationId xmlns:a16="http://schemas.microsoft.com/office/drawing/2014/main" id="{5063C486-60B4-4752-9DC9-E4BF7BEF1319}"/>
+                <a16:creationId xmlns:a16="http://schemas.microsoft.com/office/drawing/2014/main" id="{0817A693-CFA5-4F1F-B05E-B824A4A1B972}"/>
               </a:ext>
             </a:extLst>
           </p:cNvPr>
@@ -4324,10 +4513,10 @@
       </p:sp>
       <p:sp>
         <p:nvSpPr>
-          <p:cNvPr id="8" name="text-20">
+          <p:cNvPr id="8" name="text-23">
             <a:extLst xmlns:a="http://schemas.openxmlformats.org/drawingml/2006/main">
               <a:ext uri="{FF2B5EF4-FFF2-40B4-BE49-F238E27FC236}">
-                <a16:creationId xmlns:a16="http://schemas.microsoft.com/office/drawing/2014/main" id="{9BDB8167-E2F4-4AF7-A524-388FB6404B45}"/>
+                <a16:creationId xmlns:a16="http://schemas.microsoft.com/office/drawing/2014/main" id="{44BDC80A-C351-4085-9603-2E1D996D7F3A}"/>
               </a:ext>
             </a:extLst>
           </p:cNvPr>
@@ -4404,10 +4593,10 @@
       </p:sp>
       <p:sp>
         <p:nvSpPr>
-          <p:cNvPr id="9" name="text-21">
+          <p:cNvPr id="9" name="text-24">
             <a:extLst xmlns:a="http://schemas.openxmlformats.org/drawingml/2006/main">
               <a:ext uri="{FF2B5EF4-FFF2-40B4-BE49-F238E27FC236}">
-                <a16:creationId xmlns:a16="http://schemas.microsoft.com/office/drawing/2014/main" id="{7B5AFEFE-9601-430F-AFCA-F2953964A334}"/>
+                <a16:creationId xmlns:a16="http://schemas.microsoft.com/office/drawing/2014/main" id="{B424B1B5-2BDE-49FB-907D-84FC750FB773}"/>
               </a:ext>
             </a:extLst>
           </p:cNvPr>
@@ -4508,7 +4697,7 @@
     </p:spTree>
     <p:extLst>
       <p:ext uri="{BB962C8B-B14F-4D97-AF65-F5344CB8AC3E}">
-        <p14:creationId xmlns:p14="http://schemas.microsoft.com/office/powerpoint/2010/main" val="708573235"/>
+        <p14:creationId xmlns:p14="http://schemas.microsoft.com/office/powerpoint/2010/main" val="74744696"/>
       </p:ext>
     </p:extLst>
   </p:cSld>
@@ -4536,10 +4725,10 @@
       </p:grpSpPr>
       <p:sp>
         <p:nvSpPr>
-          <p:cNvPr id="18" name="text-22">
+          <p:cNvPr id="18" name="text-25">
             <a:extLst xmlns:a="http://schemas.openxmlformats.org/drawingml/2006/main">
               <a:ext uri="{FF2B5EF4-FFF2-40B4-BE49-F238E27FC236}">
-                <a16:creationId xmlns:a16="http://schemas.microsoft.com/office/drawing/2014/main" id="{60A17B9C-FC91-49FD-B27B-A406A89CDE15}"/>
+                <a16:creationId xmlns:a16="http://schemas.microsoft.com/office/drawing/2014/main" id="{1D99BF04-A9BE-44ED-8E72-79DAA31B6DB9}"/>
               </a:ext>
             </a:extLst>
           </p:cNvPr>
@@ -4593,10 +4782,10 @@
       </p:sp>
       <p:sp>
         <p:nvSpPr>
-          <p:cNvPr id="2" name="text-23">
+          <p:cNvPr id="2" name="text-26">
             <a:extLst xmlns:a="http://schemas.openxmlformats.org/drawingml/2006/main">
               <a:ext uri="{FF2B5EF4-FFF2-40B4-BE49-F238E27FC236}">
-                <a16:creationId xmlns:a16="http://schemas.microsoft.com/office/drawing/2014/main" id="{71708588-AD12-4D93-9AFC-957B26EBCAF5}"/>
+                <a16:creationId xmlns:a16="http://schemas.microsoft.com/office/drawing/2014/main" id="{0454DEBB-4707-4919-A1F1-3EE6A98E8942}"/>
               </a:ext>
             </a:extLst>
           </p:cNvPr>
@@ -4653,7 +4842,7 @@
           <p:cNvPr id="3" name="">
             <a:extLst xmlns:a="http://schemas.openxmlformats.org/drawingml/2006/main">
               <a:ext uri="{FF2B5EF4-FFF2-40B4-BE49-F238E27FC236}">
-                <a16:creationId xmlns:a16="http://schemas.microsoft.com/office/drawing/2014/main" id="{A20D4C32-A10A-48D9-B0E8-598FE698A777}"/>
+                <a16:creationId xmlns:a16="http://schemas.microsoft.com/office/drawing/2014/main" id="{F8D8A478-9D19-4073-9C31-411D4B8F8601}"/>
               </a:ext>
             </a:extLst>
           </p:cNvPr>
@@ -4680,10 +4869,10 @@
       </p:sp>
       <p:sp>
         <p:nvSpPr>
-          <p:cNvPr id="4" name="text-24">
+          <p:cNvPr id="4" name="text-27">
             <a:extLst xmlns:a="http://schemas.openxmlformats.org/drawingml/2006/main">
               <a:ext uri="{FF2B5EF4-FFF2-40B4-BE49-F238E27FC236}">
-                <a16:creationId xmlns:a16="http://schemas.microsoft.com/office/drawing/2014/main" id="{4BA5A2E1-0269-4B4F-B737-2F0DEED77BDA}"/>
+                <a16:creationId xmlns:a16="http://schemas.microsoft.com/office/drawing/2014/main" id="{0B8814CD-746C-4C1A-96A0-772C5ECB56E3}"/>
               </a:ext>
             </a:extLst>
           </p:cNvPr>
@@ -4737,10 +4926,10 @@
       </p:sp>
       <p:sp>
         <p:nvSpPr>
-          <p:cNvPr id="5" name="text-25">
+          <p:cNvPr id="5" name="text-28">
             <a:extLst xmlns:a="http://schemas.openxmlformats.org/drawingml/2006/main">
               <a:ext uri="{FF2B5EF4-FFF2-40B4-BE49-F238E27FC236}">
-                <a16:creationId xmlns:a16="http://schemas.microsoft.com/office/drawing/2014/main" id="{FF02586C-81DF-438D-889A-F8BDDFA7D418}"/>
+                <a16:creationId xmlns:a16="http://schemas.microsoft.com/office/drawing/2014/main" id="{A6E201BF-BD35-415B-9A40-645A36E77936}"/>
               </a:ext>
             </a:extLst>
           </p:cNvPr>
@@ -4801,7 +4990,7 @@
           <p:nvPr/>
         </p:nvPicPr>
         <p:blipFill>
-          <a:blip xmlns:r="http://schemas.openxmlformats.org/officeDocument/2006/relationships" xmlns:a="http://schemas.openxmlformats.org/drawingml/2006/main" r:embed="Ra9260f33c41b4168"/>
+          <a:blip xmlns:r="http://schemas.openxmlformats.org/officeDocument/2006/relationships" xmlns:a="http://schemas.openxmlformats.org/drawingml/2006/main" r:embed="R4b2e8e511bc242ef"/>
           <a:srcRect xmlns:a="http://schemas.openxmlformats.org/drawingml/2006/main" l="77" t="0" r="77" b="0"/>
           <a:stretch xmlns:a="http://schemas.openxmlformats.org/drawingml/2006/main">
             <a:fillRect l="0" t="0" r="0" b="0"/>
@@ -4819,10 +5008,10 @@
       </p:pic>
       <p:sp>
         <p:nvSpPr>
-          <p:cNvPr id="7" name="text-26">
+          <p:cNvPr id="7" name="text-29">
             <a:extLst xmlns:a="http://schemas.openxmlformats.org/drawingml/2006/main">
               <a:ext uri="{FF2B5EF4-FFF2-40B4-BE49-F238E27FC236}">
-                <a16:creationId xmlns:a16="http://schemas.microsoft.com/office/drawing/2014/main" id="{116E48BB-077C-4C2E-B97D-E1550FDE98F5}"/>
+                <a16:creationId xmlns:a16="http://schemas.microsoft.com/office/drawing/2014/main" id="{25387D84-FFD7-451E-9A4B-800A2CFC3672}"/>
               </a:ext>
             </a:extLst>
           </p:cNvPr>
@@ -4876,10 +5065,10 @@
       </p:sp>
       <p:sp>
         <p:nvSpPr>
-          <p:cNvPr id="8" name="text-27">
+          <p:cNvPr id="8" name="text-30">
             <a:extLst xmlns:a="http://schemas.openxmlformats.org/drawingml/2006/main">
               <a:ext uri="{FF2B5EF4-FFF2-40B4-BE49-F238E27FC236}">
-                <a16:creationId xmlns:a16="http://schemas.microsoft.com/office/drawing/2014/main" id="{6406B18C-D583-429C-96F7-330D1041D1FB}"/>
+                <a16:creationId xmlns:a16="http://schemas.microsoft.com/office/drawing/2014/main" id="{AC97DE62-3DC5-40F3-ACFD-31AE512B6D91}"/>
               </a:ext>
             </a:extLst>
           </p:cNvPr>
@@ -4933,10 +5122,10 @@
       </p:sp>
       <p:sp>
         <p:nvSpPr>
-          <p:cNvPr id="9" name="node-28">
+          <p:cNvPr id="9" name="node-31">
             <a:extLst xmlns:a="http://schemas.openxmlformats.org/drawingml/2006/main">
               <a:ext uri="{FF2B5EF4-FFF2-40B4-BE49-F238E27FC236}">
-                <a16:creationId xmlns:a16="http://schemas.microsoft.com/office/drawing/2014/main" id="{02A7E981-2BB2-4068-9AA6-A30629439644}"/>
+                <a16:creationId xmlns:a16="http://schemas.microsoft.com/office/drawing/2014/main" id="{0FCA543E-0DBC-4CB1-A215-0FF9ABC49D9E}"/>
               </a:ext>
             </a:extLst>
           </p:cNvPr>
@@ -5017,10 +5206,10 @@
       </p:sp>
       <p:sp>
         <p:nvSpPr>
-          <p:cNvPr id="10" name="node-29">
+          <p:cNvPr id="10" name="node-32">
             <a:extLst xmlns:a="http://schemas.openxmlformats.org/drawingml/2006/main">
               <a:ext uri="{FF2B5EF4-FFF2-40B4-BE49-F238E27FC236}">
-                <a16:creationId xmlns:a16="http://schemas.microsoft.com/office/drawing/2014/main" id="{7F559502-552F-4A8C-B5AC-E561CAD61C93}"/>
+                <a16:creationId xmlns:a16="http://schemas.microsoft.com/office/drawing/2014/main" id="{78C794B6-B997-411D-B4FE-2769159F5E04}"/>
               </a:ext>
             </a:extLst>
           </p:cNvPr>
@@ -5101,10 +5290,10 @@
       </p:sp>
       <p:sp>
         <p:nvSpPr>
-          <p:cNvPr id="11" name="node-30">
+          <p:cNvPr id="11" name="node-33">
             <a:extLst xmlns:a="http://schemas.openxmlformats.org/drawingml/2006/main">
               <a:ext uri="{FF2B5EF4-FFF2-40B4-BE49-F238E27FC236}">
-                <a16:creationId xmlns:a16="http://schemas.microsoft.com/office/drawing/2014/main" id="{8F46939B-22A0-4B0C-B63C-A8583CF30AFD}"/>
+                <a16:creationId xmlns:a16="http://schemas.microsoft.com/office/drawing/2014/main" id="{D9B89527-51C7-411B-A783-418F2E487FDF}"/>
               </a:ext>
             </a:extLst>
           </p:cNvPr>
@@ -5208,10 +5397,10 @@
       </p:sp>
       <p:sp>
         <p:nvSpPr>
-          <p:cNvPr id="12" name="node-31">
+          <p:cNvPr id="12" name="node-34">
             <a:extLst xmlns:a="http://schemas.openxmlformats.org/drawingml/2006/main">
               <a:ext uri="{FF2B5EF4-FFF2-40B4-BE49-F238E27FC236}">
-                <a16:creationId xmlns:a16="http://schemas.microsoft.com/office/drawing/2014/main" id="{1AE05503-C1B7-451F-8F7D-DA06F69FBD5D}"/>
+                <a16:creationId xmlns:a16="http://schemas.microsoft.com/office/drawing/2014/main" id="{14DC5E89-812F-4163-A192-02E11433A881}"/>
               </a:ext>
             </a:extLst>
           </p:cNvPr>
@@ -5390,10 +5579,10 @@
       </p:cxnSp>
       <p:sp>
         <p:nvSpPr>
-          <p:cNvPr id="16" name="text-32">
+          <p:cNvPr id="16" name="text-35">
             <a:extLst xmlns:a="http://schemas.openxmlformats.org/drawingml/2006/main">
               <a:ext uri="{FF2B5EF4-FFF2-40B4-BE49-F238E27FC236}">
-                <a16:creationId xmlns:a16="http://schemas.microsoft.com/office/drawing/2014/main" id="{1CDE1377-3696-4886-994C-239F9B672410}"/>
+                <a16:creationId xmlns:a16="http://schemas.microsoft.com/office/drawing/2014/main" id="{E0DA2DC9-054C-4F29-8B6A-DFA11525BE75}"/>
               </a:ext>
             </a:extLst>
           </p:cNvPr>
@@ -5493,10 +5682,10 @@
       </p:sp>
       <p:sp>
         <p:nvSpPr>
-          <p:cNvPr id="17" name="text-33">
+          <p:cNvPr id="17" name="text-36">
             <a:extLst xmlns:a="http://schemas.openxmlformats.org/drawingml/2006/main">
               <a:ext uri="{FF2B5EF4-FFF2-40B4-BE49-F238E27FC236}">
-                <a16:creationId xmlns:a16="http://schemas.microsoft.com/office/drawing/2014/main" id="{8C8AA2B4-DD25-430A-A867-5D36CAAAFBF6}"/>
+                <a16:creationId xmlns:a16="http://schemas.microsoft.com/office/drawing/2014/main" id="{2C45347C-B150-4A74-8A33-D9D87B09D064}"/>
               </a:ext>
             </a:extLst>
           </p:cNvPr>
@@ -5551,7 +5740,7 @@
     </p:spTree>
     <p:extLst>
       <p:ext uri="{BB962C8B-B14F-4D97-AF65-F5344CB8AC3E}">
-        <p14:creationId xmlns:p14="http://schemas.microsoft.com/office/powerpoint/2010/main" val="331355143"/>
+        <p14:creationId xmlns:p14="http://schemas.microsoft.com/office/powerpoint/2010/main" val="1130173884"/>
       </p:ext>
     </p:extLst>
   </p:cSld>
@@ -5579,10 +5768,10 @@
       </p:grpSpPr>
       <p:sp>
         <p:nvSpPr>
-          <p:cNvPr id="9" name="text-34">
+          <p:cNvPr id="9" name="text-37">
             <a:extLst xmlns:a="http://schemas.openxmlformats.org/drawingml/2006/main">
               <a:ext uri="{FF2B5EF4-FFF2-40B4-BE49-F238E27FC236}">
-                <a16:creationId xmlns:a16="http://schemas.microsoft.com/office/drawing/2014/main" id="{71315F94-B0BB-4A1C-BE81-7D41159634FA}"/>
+                <a16:creationId xmlns:a16="http://schemas.microsoft.com/office/drawing/2014/main" id="{C52D4CF0-F4F9-43D6-9B3B-45EF533D1A25}"/>
               </a:ext>
             </a:extLst>
           </p:cNvPr>
@@ -5636,10 +5825,10 @@
       </p:sp>
       <p:sp>
         <p:nvSpPr>
-          <p:cNvPr id="2" name="text-35">
+          <p:cNvPr id="2" name="text-38">
             <a:extLst xmlns:a="http://schemas.openxmlformats.org/drawingml/2006/main">
               <a:ext uri="{FF2B5EF4-FFF2-40B4-BE49-F238E27FC236}">
-                <a16:creationId xmlns:a16="http://schemas.microsoft.com/office/drawing/2014/main" id="{88184FA1-9127-47F9-A42D-8FB02156CA5C}"/>
+                <a16:creationId xmlns:a16="http://schemas.microsoft.com/office/drawing/2014/main" id="{E5F1A074-1005-4254-A6DC-1D7355457A81}"/>
               </a:ext>
             </a:extLst>
           </p:cNvPr>
@@ -5696,7 +5885,7 @@
           <p:cNvPr id="3" name="">
             <a:extLst xmlns:a="http://schemas.openxmlformats.org/drawingml/2006/main">
               <a:ext uri="{FF2B5EF4-FFF2-40B4-BE49-F238E27FC236}">
-                <a16:creationId xmlns:a16="http://schemas.microsoft.com/office/drawing/2014/main" id="{52D971D7-7057-4910-8474-4AF956C705DB}"/>
+                <a16:creationId xmlns:a16="http://schemas.microsoft.com/office/drawing/2014/main" id="{63EE6CCA-CC02-4F84-929D-FF6059445696}"/>
               </a:ext>
             </a:extLst>
           </p:cNvPr>
@@ -5723,10 +5912,10 @@
       </p:sp>
       <p:sp>
         <p:nvSpPr>
-          <p:cNvPr id="4" name="text-36">
+          <p:cNvPr id="4" name="text-39">
             <a:extLst xmlns:a="http://schemas.openxmlformats.org/drawingml/2006/main">
               <a:ext uri="{FF2B5EF4-FFF2-40B4-BE49-F238E27FC236}">
-                <a16:creationId xmlns:a16="http://schemas.microsoft.com/office/drawing/2014/main" id="{490ACF52-D310-4CF6-A767-4F0F2D1D18EC}"/>
+                <a16:creationId xmlns:a16="http://schemas.microsoft.com/office/drawing/2014/main" id="{99AF4C52-5A82-4FFA-8B48-D1E2CE0A59B4}"/>
               </a:ext>
             </a:extLst>
           </p:cNvPr>
@@ -5780,10 +5969,10 @@
       </p:sp>
       <p:sp>
         <p:nvSpPr>
-          <p:cNvPr id="5" name="text-37">
+          <p:cNvPr id="5" name="text-40">
             <a:extLst xmlns:a="http://schemas.openxmlformats.org/drawingml/2006/main">
               <a:ext uri="{FF2B5EF4-FFF2-40B4-BE49-F238E27FC236}">
-                <a16:creationId xmlns:a16="http://schemas.microsoft.com/office/drawing/2014/main" id="{57E8B0CB-B68E-4DB2-A981-5CBD7C2BFC69}"/>
+                <a16:creationId xmlns:a16="http://schemas.microsoft.com/office/drawing/2014/main" id="{08B4FB30-0E68-4FAD-85C4-E142239262B5}"/>
               </a:ext>
             </a:extLst>
           </p:cNvPr>
@@ -6180,10 +6369,10 @@
       </p:graphicFrame>
       <p:sp>
         <p:nvSpPr>
-          <p:cNvPr id="7" name="text-38">
+          <p:cNvPr id="7" name="text-41">
             <a:extLst xmlns:a="http://schemas.openxmlformats.org/drawingml/2006/main">
               <a:ext uri="{FF2B5EF4-FFF2-40B4-BE49-F238E27FC236}">
-                <a16:creationId xmlns:a16="http://schemas.microsoft.com/office/drawing/2014/main" id="{27D7C2B9-401C-4AD4-A59D-2C9824DFBDD9}"/>
+                <a16:creationId xmlns:a16="http://schemas.microsoft.com/office/drawing/2014/main" id="{1A86C65A-6CE4-4DFD-8839-A5D4F2A8D6A7}"/>
               </a:ext>
             </a:extLst>
           </p:cNvPr>
@@ -6237,10 +6426,10 @@
       </p:sp>
       <p:sp>
         <p:nvSpPr>
-          <p:cNvPr id="8" name="text-39">
+          <p:cNvPr id="8" name="text-42">
             <a:extLst xmlns:a="http://schemas.openxmlformats.org/drawingml/2006/main">
               <a:ext uri="{FF2B5EF4-FFF2-40B4-BE49-F238E27FC236}">
-                <a16:creationId xmlns:a16="http://schemas.microsoft.com/office/drawing/2014/main" id="{0E3861E7-E334-477F-9BB2-B61109E6D72A}"/>
+                <a16:creationId xmlns:a16="http://schemas.microsoft.com/office/drawing/2014/main" id="{EE6A56E3-52AE-4AEE-AAE5-5D85491EED81}"/>
               </a:ext>
             </a:extLst>
           </p:cNvPr>
@@ -6295,7 +6484,7 @@
     </p:spTree>
     <p:extLst>
       <p:ext uri="{BB962C8B-B14F-4D97-AF65-F5344CB8AC3E}">
-        <p14:creationId xmlns:p14="http://schemas.microsoft.com/office/powerpoint/2010/main" val="369053783"/>
+        <p14:creationId xmlns:p14="http://schemas.microsoft.com/office/powerpoint/2010/main" val="260344465"/>
       </p:ext>
     </p:extLst>
   </p:cSld>
@@ -6323,10 +6512,10 @@
       </p:grpSpPr>
       <p:sp>
         <p:nvSpPr>
-          <p:cNvPr id="18" name="text-40">
+          <p:cNvPr id="18" name="text-43">
             <a:extLst xmlns:a="http://schemas.openxmlformats.org/drawingml/2006/main">
               <a:ext uri="{FF2B5EF4-FFF2-40B4-BE49-F238E27FC236}">
-                <a16:creationId xmlns:a16="http://schemas.microsoft.com/office/drawing/2014/main" id="{93D90FDF-FA1D-4710-A34C-1B4F85E3AE96}"/>
+                <a16:creationId xmlns:a16="http://schemas.microsoft.com/office/drawing/2014/main" id="{B141B6F2-9671-4C4B-86C8-B68C6798C0F0}"/>
               </a:ext>
             </a:extLst>
           </p:cNvPr>
@@ -6380,10 +6569,10 @@
       </p:sp>
       <p:sp>
         <p:nvSpPr>
-          <p:cNvPr id="2" name="text-41">
+          <p:cNvPr id="2" name="text-44">
             <a:extLst xmlns:a="http://schemas.openxmlformats.org/drawingml/2006/main">
               <a:ext uri="{FF2B5EF4-FFF2-40B4-BE49-F238E27FC236}">
-                <a16:creationId xmlns:a16="http://schemas.microsoft.com/office/drawing/2014/main" id="{7958669B-A1B0-4E7A-A99C-95D52F068829}"/>
+                <a16:creationId xmlns:a16="http://schemas.microsoft.com/office/drawing/2014/main" id="{B117E85E-C267-4732-A02A-F4DC395B4F13}"/>
               </a:ext>
             </a:extLst>
           </p:cNvPr>
@@ -6440,7 +6629,7 @@
           <p:cNvPr id="3" name="">
             <a:extLst xmlns:a="http://schemas.openxmlformats.org/drawingml/2006/main">
               <a:ext uri="{FF2B5EF4-FFF2-40B4-BE49-F238E27FC236}">
-                <a16:creationId xmlns:a16="http://schemas.microsoft.com/office/drawing/2014/main" id="{0C258B0F-DFAB-406F-A24C-F4CA05E1A6F3}"/>
+                <a16:creationId xmlns:a16="http://schemas.microsoft.com/office/drawing/2014/main" id="{C93E41D8-B627-47E7-91B8-E9072E31DD1A}"/>
               </a:ext>
             </a:extLst>
           </p:cNvPr>
@@ -6467,10 +6656,10 @@
       </p:sp>
       <p:sp>
         <p:nvSpPr>
-          <p:cNvPr id="4" name="text-42">
+          <p:cNvPr id="4" name="text-45">
             <a:extLst xmlns:a="http://schemas.openxmlformats.org/drawingml/2006/main">
               <a:ext uri="{FF2B5EF4-FFF2-40B4-BE49-F238E27FC236}">
-                <a16:creationId xmlns:a16="http://schemas.microsoft.com/office/drawing/2014/main" id="{FA89A8AB-0E8F-4130-89A0-724BAAAE2371}"/>
+                <a16:creationId xmlns:a16="http://schemas.microsoft.com/office/drawing/2014/main" id="{07EAC640-6921-493F-80E9-1ABA3577788B}"/>
               </a:ext>
             </a:extLst>
           </p:cNvPr>
@@ -6524,10 +6713,10 @@
       </p:sp>
       <p:sp>
         <p:nvSpPr>
-          <p:cNvPr id="5" name="text-43">
+          <p:cNvPr id="5" name="text-46">
             <a:extLst xmlns:a="http://schemas.openxmlformats.org/drawingml/2006/main">
               <a:ext uri="{FF2B5EF4-FFF2-40B4-BE49-F238E27FC236}">
-                <a16:creationId xmlns:a16="http://schemas.microsoft.com/office/drawing/2014/main" id="{EC61ECD8-5E04-4732-BB21-53F3DF603C24}"/>
+                <a16:creationId xmlns:a16="http://schemas.microsoft.com/office/drawing/2014/main" id="{A7D49EAC-173D-4265-A5FE-319DC33FE425}"/>
               </a:ext>
             </a:extLst>
           </p:cNvPr>
@@ -6581,10 +6770,10 @@
       </p:sp>
       <p:sp>
         <p:nvSpPr>
-          <p:cNvPr id="6" name="node-44">
+          <p:cNvPr id="6" name="node-47">
             <a:extLst xmlns:a="http://schemas.openxmlformats.org/drawingml/2006/main">
               <a:ext uri="{FF2B5EF4-FFF2-40B4-BE49-F238E27FC236}">
-                <a16:creationId xmlns:a16="http://schemas.microsoft.com/office/drawing/2014/main" id="{671B8377-8A7C-44FF-8698-BFB30C531D08}"/>
+                <a16:creationId xmlns:a16="http://schemas.microsoft.com/office/drawing/2014/main" id="{E460E3E7-27A9-4594-8445-DC0C5439D9E4}"/>
               </a:ext>
             </a:extLst>
           </p:cNvPr>
@@ -6665,10 +6854,10 @@
       </p:sp>
       <p:sp>
         <p:nvSpPr>
-          <p:cNvPr id="7" name="node-45">
+          <p:cNvPr id="7" name="node-48">
             <a:extLst xmlns:a="http://schemas.openxmlformats.org/drawingml/2006/main">
               <a:ext uri="{FF2B5EF4-FFF2-40B4-BE49-F238E27FC236}">
-                <a16:creationId xmlns:a16="http://schemas.microsoft.com/office/drawing/2014/main" id="{7BCAAAEA-1CDE-4974-B853-EFDEF729D740}"/>
+                <a16:creationId xmlns:a16="http://schemas.microsoft.com/office/drawing/2014/main" id="{322BBFB1-9746-4759-9D95-9A3E0B82D00D}"/>
               </a:ext>
             </a:extLst>
           </p:cNvPr>
@@ -6749,10 +6938,10 @@
       </p:sp>
       <p:sp>
         <p:nvSpPr>
-          <p:cNvPr id="8" name="node-46">
+          <p:cNvPr id="8" name="node-49">
             <a:extLst xmlns:a="http://schemas.openxmlformats.org/drawingml/2006/main">
               <a:ext uri="{FF2B5EF4-FFF2-40B4-BE49-F238E27FC236}">
-                <a16:creationId xmlns:a16="http://schemas.microsoft.com/office/drawing/2014/main" id="{53FF9727-BFB1-4553-86BC-732D8ADDC332}"/>
+                <a16:creationId xmlns:a16="http://schemas.microsoft.com/office/drawing/2014/main" id="{10FC77FD-E805-44A3-AE6A-583101A1405F}"/>
               </a:ext>
             </a:extLst>
           </p:cNvPr>
@@ -6833,10 +7022,10 @@
       </p:sp>
       <p:sp>
         <p:nvSpPr>
-          <p:cNvPr id="9" name="node-47">
+          <p:cNvPr id="9" name="node-50">
             <a:extLst xmlns:a="http://schemas.openxmlformats.org/drawingml/2006/main">
               <a:ext uri="{FF2B5EF4-FFF2-40B4-BE49-F238E27FC236}">
-                <a16:creationId xmlns:a16="http://schemas.microsoft.com/office/drawing/2014/main" id="{56E12569-9A8B-4F4C-A775-7951C0AE2769}"/>
+                <a16:creationId xmlns:a16="http://schemas.microsoft.com/office/drawing/2014/main" id="{37094A2B-5290-4822-9523-808E0FB7E3FA}"/>
               </a:ext>
             </a:extLst>
           </p:cNvPr>
@@ -6917,10 +7106,10 @@
       </p:sp>
       <p:sp>
         <p:nvSpPr>
-          <p:cNvPr id="10" name="node-48">
+          <p:cNvPr id="10" name="node-51">
             <a:extLst xmlns:a="http://schemas.openxmlformats.org/drawingml/2006/main">
               <a:ext uri="{FF2B5EF4-FFF2-40B4-BE49-F238E27FC236}">
-                <a16:creationId xmlns:a16="http://schemas.microsoft.com/office/drawing/2014/main" id="{AF8E6546-3FA9-4D8D-A5A5-8061C6E8427A}"/>
+                <a16:creationId xmlns:a16="http://schemas.microsoft.com/office/drawing/2014/main" id="{B2C5ECC3-167E-4322-91FD-F20B9E419809}"/>
               </a:ext>
             </a:extLst>
           </p:cNvPr>
@@ -7001,10 +7190,10 @@
       </p:sp>
       <p:sp>
         <p:nvSpPr>
-          <p:cNvPr id="11" name="node-49">
+          <p:cNvPr id="11" name="node-52">
             <a:extLst xmlns:a="http://schemas.openxmlformats.org/drawingml/2006/main">
               <a:ext uri="{FF2B5EF4-FFF2-40B4-BE49-F238E27FC236}">
-                <a16:creationId xmlns:a16="http://schemas.microsoft.com/office/drawing/2014/main" id="{0738CE40-90BE-4B8E-AEA1-A1A6FC0F88A8}"/>
+                <a16:creationId xmlns:a16="http://schemas.microsoft.com/office/drawing/2014/main" id="{C620FE01-A736-4C79-91DD-00C89BD1CE8A}"/>
               </a:ext>
             </a:extLst>
           </p:cNvPr>
@@ -7210,10 +7399,10 @@
       </p:cxnSp>
       <p:sp>
         <p:nvSpPr>
-          <p:cNvPr id="17" name="text-50">
+          <p:cNvPr id="17" name="text-53">
             <a:extLst xmlns:a="http://schemas.openxmlformats.org/drawingml/2006/main">
               <a:ext uri="{FF2B5EF4-FFF2-40B4-BE49-F238E27FC236}">
-                <a16:creationId xmlns:a16="http://schemas.microsoft.com/office/drawing/2014/main" id="{66C24916-B3E7-4CF7-A015-8154A00DE0D4}"/>
+                <a16:creationId xmlns:a16="http://schemas.microsoft.com/office/drawing/2014/main" id="{B361DFCB-B39D-4B03-9FF3-31A631636AB5}"/>
               </a:ext>
             </a:extLst>
           </p:cNvPr>
@@ -7268,7 +7457,7 @@
     </p:spTree>
     <p:extLst>
       <p:ext uri="{BB962C8B-B14F-4D97-AF65-F5344CB8AC3E}">
-        <p14:creationId xmlns:p14="http://schemas.microsoft.com/office/powerpoint/2010/main" val="829697646"/>
+        <p14:creationId xmlns:p14="http://schemas.microsoft.com/office/powerpoint/2010/main" val="1959953263"/>
       </p:ext>
     </p:extLst>
   </p:cSld>
@@ -7296,10 +7485,10 @@
       </p:grpSpPr>
       <p:sp>
         <p:nvSpPr>
-          <p:cNvPr id="14" name="text-51">
+          <p:cNvPr id="14" name="text-54">
             <a:extLst xmlns:a="http://schemas.openxmlformats.org/drawingml/2006/main">
               <a:ext uri="{FF2B5EF4-FFF2-40B4-BE49-F238E27FC236}">
-                <a16:creationId xmlns:a16="http://schemas.microsoft.com/office/drawing/2014/main" id="{4F89C720-223F-4642-9D61-BF5553DA97E6}"/>
+                <a16:creationId xmlns:a16="http://schemas.microsoft.com/office/drawing/2014/main" id="{33FC9CCA-47AD-42B6-8B99-81BECC7CBD58}"/>
               </a:ext>
             </a:extLst>
           </p:cNvPr>
@@ -7353,10 +7542,10 @@
       </p:sp>
       <p:sp>
         <p:nvSpPr>
-          <p:cNvPr id="2" name="text-52">
+          <p:cNvPr id="2" name="text-55">
             <a:extLst xmlns:a="http://schemas.openxmlformats.org/drawingml/2006/main">
               <a:ext uri="{FF2B5EF4-FFF2-40B4-BE49-F238E27FC236}">
-                <a16:creationId xmlns:a16="http://schemas.microsoft.com/office/drawing/2014/main" id="{7D9F2B74-5397-4B77-8ADB-7D7A02F8B712}"/>
+                <a16:creationId xmlns:a16="http://schemas.microsoft.com/office/drawing/2014/main" id="{EAECAA3B-1E99-4C35-9968-445579033810}"/>
               </a:ext>
             </a:extLst>
           </p:cNvPr>
@@ -7413,7 +7602,7 @@
           <p:cNvPr id="3" name="">
             <a:extLst xmlns:a="http://schemas.openxmlformats.org/drawingml/2006/main">
               <a:ext uri="{FF2B5EF4-FFF2-40B4-BE49-F238E27FC236}">
-                <a16:creationId xmlns:a16="http://schemas.microsoft.com/office/drawing/2014/main" id="{C87438E7-7B99-417B-9384-EF41B20FF0A4}"/>
+                <a16:creationId xmlns:a16="http://schemas.microsoft.com/office/drawing/2014/main" id="{CF6E556E-1CE9-408F-A1E0-5513E07B0D1B}"/>
               </a:ext>
             </a:extLst>
           </p:cNvPr>
@@ -7440,10 +7629,10 @@
       </p:sp>
       <p:sp>
         <p:nvSpPr>
-          <p:cNvPr id="4" name="text-53">
+          <p:cNvPr id="4" name="text-56">
             <a:extLst xmlns:a="http://schemas.openxmlformats.org/drawingml/2006/main">
               <a:ext uri="{FF2B5EF4-FFF2-40B4-BE49-F238E27FC236}">
-                <a16:creationId xmlns:a16="http://schemas.microsoft.com/office/drawing/2014/main" id="{ABF1C3EA-EC6A-4245-9B1A-AEF495508392}"/>
+                <a16:creationId xmlns:a16="http://schemas.microsoft.com/office/drawing/2014/main" id="{5B0EA030-F329-4903-BC52-2CD5CAF16750}"/>
               </a:ext>
             </a:extLst>
           </p:cNvPr>
@@ -7497,10 +7686,10 @@
       </p:sp>
       <p:sp>
         <p:nvSpPr>
-          <p:cNvPr id="5" name="text-54">
+          <p:cNvPr id="5" name="text-57">
             <a:extLst xmlns:a="http://schemas.openxmlformats.org/drawingml/2006/main">
               <a:ext uri="{FF2B5EF4-FFF2-40B4-BE49-F238E27FC236}">
-                <a16:creationId xmlns:a16="http://schemas.microsoft.com/office/drawing/2014/main" id="{238C69D9-02CB-4D08-B99F-8CD6DC89D854}"/>
+                <a16:creationId xmlns:a16="http://schemas.microsoft.com/office/drawing/2014/main" id="{610F3920-8B45-450C-9DE7-5305AFC971C2}"/>
               </a:ext>
             </a:extLst>
           </p:cNvPr>
@@ -7557,7 +7746,7 @@
           <p:cNvPr id="6" name="">
             <a:extLst xmlns:a="http://schemas.openxmlformats.org/drawingml/2006/main">
               <a:ext uri="{FF2B5EF4-FFF2-40B4-BE49-F238E27FC236}">
-                <a16:creationId xmlns:a16="http://schemas.microsoft.com/office/drawing/2014/main" id="{BB1C7ED2-68EB-4A43-9A19-69026A011838}"/>
+                <a16:creationId xmlns:a16="http://schemas.microsoft.com/office/drawing/2014/main" id="{8479DCE5-6CDC-436E-A6F9-1AE29E56F2E5}"/>
               </a:ext>
             </a:extLst>
           </p:cNvPr>
@@ -7584,10 +7773,10 @@
       </p:sp>
       <p:sp>
         <p:nvSpPr>
-          <p:cNvPr id="7" name="text-55">
+          <p:cNvPr id="7" name="text-58">
             <a:extLst xmlns:a="http://schemas.openxmlformats.org/drawingml/2006/main">
               <a:ext uri="{FF2B5EF4-FFF2-40B4-BE49-F238E27FC236}">
-                <a16:creationId xmlns:a16="http://schemas.microsoft.com/office/drawing/2014/main" id="{8D99C85E-032B-4EDB-A22D-3C1768ADC1A5}"/>
+                <a16:creationId xmlns:a16="http://schemas.microsoft.com/office/drawing/2014/main" id="{805CB344-05BC-4063-9F17-04970C4F6C16}"/>
               </a:ext>
             </a:extLst>
           </p:cNvPr>
@@ -7641,10 +7830,10 @@
       </p:sp>
       <p:sp>
         <p:nvSpPr>
-          <p:cNvPr id="8" name="text-56">
+          <p:cNvPr id="8" name="text-59">
             <a:extLst xmlns:a="http://schemas.openxmlformats.org/drawingml/2006/main">
               <a:ext uri="{FF2B5EF4-FFF2-40B4-BE49-F238E27FC236}">
-                <a16:creationId xmlns:a16="http://schemas.microsoft.com/office/drawing/2014/main" id="{AA906953-768A-4A1D-B8D4-43FACBC51430}"/>
+                <a16:creationId xmlns:a16="http://schemas.microsoft.com/office/drawing/2014/main" id="{4E1A7423-1C93-4FD7-B3D9-FCE82BCCCEAF}"/>
               </a:ext>
             </a:extLst>
           </p:cNvPr>
@@ -7698,10 +7887,10 @@
       </p:sp>
       <p:sp>
         <p:nvSpPr>
-          <p:cNvPr id="9" name="text-57">
+          <p:cNvPr id="9" name="text-60">
             <a:extLst xmlns:a="http://schemas.openxmlformats.org/drawingml/2006/main">
               <a:ext uri="{FF2B5EF4-FFF2-40B4-BE49-F238E27FC236}">
-                <a16:creationId xmlns:a16="http://schemas.microsoft.com/office/drawing/2014/main" id="{A76ADC36-8F99-4595-92C9-0F7687AD5439}"/>
+                <a16:creationId xmlns:a16="http://schemas.microsoft.com/office/drawing/2014/main" id="{A71E4D47-A684-4855-B1EA-4259D465EF64}"/>
               </a:ext>
             </a:extLst>
           </p:cNvPr>
@@ -7824,10 +8013,10 @@
       </p:sp>
       <p:sp>
         <p:nvSpPr>
-          <p:cNvPr id="10" name="text-58">
+          <p:cNvPr id="10" name="text-61">
             <a:extLst xmlns:a="http://schemas.openxmlformats.org/drawingml/2006/main">
               <a:ext uri="{FF2B5EF4-FFF2-40B4-BE49-F238E27FC236}">
-                <a16:creationId xmlns:a16="http://schemas.microsoft.com/office/drawing/2014/main" id="{8875DA19-AA16-4EC2-9F0A-692B51DE66CF}"/>
+                <a16:creationId xmlns:a16="http://schemas.microsoft.com/office/drawing/2014/main" id="{464624CC-E910-4608-BBA4-62550D60EA88}"/>
               </a:ext>
             </a:extLst>
           </p:cNvPr>
@@ -7953,7 +8142,7 @@
           <p:cNvPr id="11" name="">
             <a:extLst xmlns:a="http://schemas.openxmlformats.org/drawingml/2006/main">
               <a:ext uri="{FF2B5EF4-FFF2-40B4-BE49-F238E27FC236}">
-                <a16:creationId xmlns:a16="http://schemas.microsoft.com/office/drawing/2014/main" id="{D5447E67-E12A-4812-B3C0-584F0C4E4F12}"/>
+                <a16:creationId xmlns:a16="http://schemas.microsoft.com/office/drawing/2014/main" id="{550F99F6-D181-46FE-BFAC-7014C1A9E4D1}"/>
               </a:ext>
             </a:extLst>
           </p:cNvPr>
@@ -7980,10 +8169,10 @@
       </p:sp>
       <p:sp>
         <p:nvSpPr>
-          <p:cNvPr id="12" name="text-59">
+          <p:cNvPr id="12" name="text-62">
             <a:extLst xmlns:a="http://schemas.openxmlformats.org/drawingml/2006/main">
               <a:ext uri="{FF2B5EF4-FFF2-40B4-BE49-F238E27FC236}">
-                <a16:creationId xmlns:a16="http://schemas.microsoft.com/office/drawing/2014/main" id="{7FCC7861-471F-41F5-A36F-55A9BD329F16}"/>
+                <a16:creationId xmlns:a16="http://schemas.microsoft.com/office/drawing/2014/main" id="{92FDD7C4-C299-421A-B578-CE7BBA348807}"/>
               </a:ext>
             </a:extLst>
           </p:cNvPr>
@@ -8037,10 +8226,10 @@
       </p:sp>
       <p:sp>
         <p:nvSpPr>
-          <p:cNvPr id="13" name="text-60">
+          <p:cNvPr id="13" name="text-63">
             <a:extLst xmlns:a="http://schemas.openxmlformats.org/drawingml/2006/main">
               <a:ext uri="{FF2B5EF4-FFF2-40B4-BE49-F238E27FC236}">
-                <a16:creationId xmlns:a16="http://schemas.microsoft.com/office/drawing/2014/main" id="{65D2AD1E-9626-4DAA-B82E-3DE7A80C8518}"/>
+                <a16:creationId xmlns:a16="http://schemas.microsoft.com/office/drawing/2014/main" id="{B32A79B4-7BBE-4259-85FC-80096A9DD365}"/>
               </a:ext>
             </a:extLst>
           </p:cNvPr>
@@ -8118,7 +8307,7 @@
     </p:spTree>
     <p:extLst>
       <p:ext uri="{BB962C8B-B14F-4D97-AF65-F5344CB8AC3E}">
-        <p14:creationId xmlns:p14="http://schemas.microsoft.com/office/powerpoint/2010/main" val="1280557009"/>
+        <p14:creationId xmlns:p14="http://schemas.microsoft.com/office/powerpoint/2010/main" val="2050569217"/>
       </p:ext>
     </p:extLst>
   </p:cSld>
@@ -8146,10 +8335,10 @@
       </p:grpSpPr>
       <p:sp>
         <p:nvSpPr>
-          <p:cNvPr id="10" name="text-61">
+          <p:cNvPr id="10" name="text-64">
             <a:extLst xmlns:a="http://schemas.openxmlformats.org/drawingml/2006/main">
               <a:ext uri="{FF2B5EF4-FFF2-40B4-BE49-F238E27FC236}">
-                <a16:creationId xmlns:a16="http://schemas.microsoft.com/office/drawing/2014/main" id="{D48A1FB8-2AFE-4290-ACCE-57797860D600}"/>
+                <a16:creationId xmlns:a16="http://schemas.microsoft.com/office/drawing/2014/main" id="{3B88CFD3-21F3-4EEE-9F95-D24998A996D3}"/>
               </a:ext>
             </a:extLst>
           </p:cNvPr>
@@ -8203,10 +8392,10 @@
       </p:sp>
       <p:sp>
         <p:nvSpPr>
-          <p:cNvPr id="2" name="text-62">
+          <p:cNvPr id="2" name="text-65">
             <a:extLst xmlns:a="http://schemas.openxmlformats.org/drawingml/2006/main">
               <a:ext uri="{FF2B5EF4-FFF2-40B4-BE49-F238E27FC236}">
-                <a16:creationId xmlns:a16="http://schemas.microsoft.com/office/drawing/2014/main" id="{AD176BB0-727C-4B4F-9BD9-7B718A7BEC8D}"/>
+                <a16:creationId xmlns:a16="http://schemas.microsoft.com/office/drawing/2014/main" id="{AEB381A4-B271-4B49-B402-3D3B3A500067}"/>
               </a:ext>
             </a:extLst>
           </p:cNvPr>
@@ -8263,7 +8452,7 @@
           <p:cNvPr id="3" name="">
             <a:extLst xmlns:a="http://schemas.openxmlformats.org/drawingml/2006/main">
               <a:ext uri="{FF2B5EF4-FFF2-40B4-BE49-F238E27FC236}">
-                <a16:creationId xmlns:a16="http://schemas.microsoft.com/office/drawing/2014/main" id="{D73B496A-BDAC-45EC-A0DA-280254160C13}"/>
+                <a16:creationId xmlns:a16="http://schemas.microsoft.com/office/drawing/2014/main" id="{95DB700C-6191-4603-8D50-9E98BB767EB9}"/>
               </a:ext>
             </a:extLst>
           </p:cNvPr>
@@ -8290,10 +8479,10 @@
       </p:sp>
       <p:sp>
         <p:nvSpPr>
-          <p:cNvPr id="4" name="text-63">
+          <p:cNvPr id="4" name="text-66">
             <a:extLst xmlns:a="http://schemas.openxmlformats.org/drawingml/2006/main">
               <a:ext uri="{FF2B5EF4-FFF2-40B4-BE49-F238E27FC236}">
-                <a16:creationId xmlns:a16="http://schemas.microsoft.com/office/drawing/2014/main" id="{6693D1C8-422C-45E6-B3D7-7150F9FAE192}"/>
+                <a16:creationId xmlns:a16="http://schemas.microsoft.com/office/drawing/2014/main" id="{2C358845-B7DB-4B4F-B484-3CCC42F90258}"/>
               </a:ext>
             </a:extLst>
           </p:cNvPr>
@@ -8347,10 +8536,10 @@
       </p:sp>
       <p:sp>
         <p:nvSpPr>
-          <p:cNvPr id="5" name="text-64">
+          <p:cNvPr id="5" name="text-67">
             <a:extLst xmlns:a="http://schemas.openxmlformats.org/drawingml/2006/main">
               <a:ext uri="{FF2B5EF4-FFF2-40B4-BE49-F238E27FC236}">
-                <a16:creationId xmlns:a16="http://schemas.microsoft.com/office/drawing/2014/main" id="{DC9C2F3D-D0F8-456C-A085-1F2C3ABCC886}"/>
+                <a16:creationId xmlns:a16="http://schemas.microsoft.com/office/drawing/2014/main" id="{84653DA2-45B3-44A5-9547-BD875CE33161}"/>
               </a:ext>
             </a:extLst>
           </p:cNvPr>
@@ -8747,10 +8936,10 @@
       </p:graphicFrame>
       <p:sp>
         <p:nvSpPr>
-          <p:cNvPr id="7" name="text-65">
+          <p:cNvPr id="7" name="text-68">
             <a:extLst xmlns:a="http://schemas.openxmlformats.org/drawingml/2006/main">
               <a:ext uri="{FF2B5EF4-FFF2-40B4-BE49-F238E27FC236}">
-                <a16:creationId xmlns:a16="http://schemas.microsoft.com/office/drawing/2014/main" id="{1E1C49F2-6814-4ED1-986D-6AB21F406A6F}"/>
+                <a16:creationId xmlns:a16="http://schemas.microsoft.com/office/drawing/2014/main" id="{717F2991-23E6-476D-813C-29B645698405}"/>
               </a:ext>
             </a:extLst>
           </p:cNvPr>
@@ -8804,10 +8993,10 @@
       </p:sp>
       <p:sp>
         <p:nvSpPr>
-          <p:cNvPr id="8" name="text-66">
+          <p:cNvPr id="8" name="text-69">
             <a:extLst xmlns:a="http://schemas.openxmlformats.org/drawingml/2006/main">
               <a:ext uri="{FF2B5EF4-FFF2-40B4-BE49-F238E27FC236}">
-                <a16:creationId xmlns:a16="http://schemas.microsoft.com/office/drawing/2014/main" id="{9073D752-EE4C-4116-9FB0-6118BDAC9AD5}"/>
+                <a16:creationId xmlns:a16="http://schemas.microsoft.com/office/drawing/2014/main" id="{E8500B33-4D33-4715-9AC1-548A5A4B0C76}"/>
               </a:ext>
             </a:extLst>
           </p:cNvPr>
@@ -8861,10 +9050,10 @@
       </p:sp>
       <p:sp>
         <p:nvSpPr>
-          <p:cNvPr id="9" name="text-67">
+          <p:cNvPr id="9" name="text-70">
             <a:extLst xmlns:a="http://schemas.openxmlformats.org/drawingml/2006/main">
               <a:ext uri="{FF2B5EF4-FFF2-40B4-BE49-F238E27FC236}">
-                <a16:creationId xmlns:a16="http://schemas.microsoft.com/office/drawing/2014/main" id="{F1F5F033-F427-47AA-A674-E8DE23EFAECF}"/>
+                <a16:creationId xmlns:a16="http://schemas.microsoft.com/office/drawing/2014/main" id="{7F500CBD-01A0-44D6-8B1E-21AD6AFEFC96}"/>
               </a:ext>
             </a:extLst>
           </p:cNvPr>
@@ -8919,7 +9108,7 @@
     </p:spTree>
     <p:extLst>
       <p:ext uri="{BB962C8B-B14F-4D97-AF65-F5344CB8AC3E}">
-        <p14:creationId xmlns:p14="http://schemas.microsoft.com/office/powerpoint/2010/main" val="563326393"/>
+        <p14:creationId xmlns:p14="http://schemas.microsoft.com/office/powerpoint/2010/main" val="1116949144"/>
       </p:ext>
     </p:extLst>
   </p:cSld>
@@ -8947,10 +9136,10 @@
       </p:grpSpPr>
       <p:sp>
         <p:nvSpPr>
-          <p:cNvPr id="10" name="text-68">
+          <p:cNvPr id="10" name="text-71">
             <a:extLst xmlns:a="http://schemas.openxmlformats.org/drawingml/2006/main">
               <a:ext uri="{FF2B5EF4-FFF2-40B4-BE49-F238E27FC236}">
-                <a16:creationId xmlns:a16="http://schemas.microsoft.com/office/drawing/2014/main" id="{446DD717-5438-43D3-A583-3E6520FC0BD5}"/>
+                <a16:creationId xmlns:a16="http://schemas.microsoft.com/office/drawing/2014/main" id="{FA44FDA3-6E59-49F8-B96E-86CA9EF6A714}"/>
               </a:ext>
             </a:extLst>
           </p:cNvPr>
@@ -9004,10 +9193,10 @@
       </p:sp>
       <p:sp>
         <p:nvSpPr>
-          <p:cNvPr id="2" name="text-69">
+          <p:cNvPr id="2" name="text-72">
             <a:extLst xmlns:a="http://schemas.openxmlformats.org/drawingml/2006/main">
               <a:ext uri="{FF2B5EF4-FFF2-40B4-BE49-F238E27FC236}">
-                <a16:creationId xmlns:a16="http://schemas.microsoft.com/office/drawing/2014/main" id="{FD717DD2-6798-483F-AB9F-3B7CF35540EF}"/>
+                <a16:creationId xmlns:a16="http://schemas.microsoft.com/office/drawing/2014/main" id="{811BE293-3591-496A-BBED-8B6663F8F9C4}"/>
               </a:ext>
             </a:extLst>
           </p:cNvPr>
@@ -9064,7 +9253,7 @@
           <p:cNvPr id="3" name="">
             <a:extLst xmlns:a="http://schemas.openxmlformats.org/drawingml/2006/main">
               <a:ext uri="{FF2B5EF4-FFF2-40B4-BE49-F238E27FC236}">
-                <a16:creationId xmlns:a16="http://schemas.microsoft.com/office/drawing/2014/main" id="{6CCDCC7E-9C12-49F8-8C5E-170A8BA9E8FD}"/>
+                <a16:creationId xmlns:a16="http://schemas.microsoft.com/office/drawing/2014/main" id="{ADA4BC1F-E4FD-423B-A5B3-645D17C76611}"/>
               </a:ext>
             </a:extLst>
           </p:cNvPr>
@@ -9091,10 +9280,10 @@
       </p:sp>
       <p:sp>
         <p:nvSpPr>
-          <p:cNvPr id="4" name="text-70">
+          <p:cNvPr id="4" name="text-73">
             <a:extLst xmlns:a="http://schemas.openxmlformats.org/drawingml/2006/main">
               <a:ext uri="{FF2B5EF4-FFF2-40B4-BE49-F238E27FC236}">
-                <a16:creationId xmlns:a16="http://schemas.microsoft.com/office/drawing/2014/main" id="{3BDD2F1C-7169-481D-B9B2-2EBCA9F4D78C}"/>
+                <a16:creationId xmlns:a16="http://schemas.microsoft.com/office/drawing/2014/main" id="{92DBDBA7-4C7C-4D9E-BDB5-27872FB54774}"/>
               </a:ext>
             </a:extLst>
           </p:cNvPr>
@@ -9148,10 +9337,10 @@
       </p:sp>
       <p:sp>
         <p:nvSpPr>
-          <p:cNvPr id="5" name="text-71">
+          <p:cNvPr id="5" name="text-74">
             <a:extLst xmlns:a="http://schemas.openxmlformats.org/drawingml/2006/main">
               <a:ext uri="{FF2B5EF4-FFF2-40B4-BE49-F238E27FC236}">
-                <a16:creationId xmlns:a16="http://schemas.microsoft.com/office/drawing/2014/main" id="{D90BEED2-DE5F-4F76-B2D8-E9E24AC678A3}"/>
+                <a16:creationId xmlns:a16="http://schemas.microsoft.com/office/drawing/2014/main" id="{AAD6CE96-3F45-4341-AA9A-FC1527F14C86}"/>
               </a:ext>
             </a:extLst>
           </p:cNvPr>
@@ -9497,10 +9686,10 @@
       </p:graphicFrame>
       <p:sp>
         <p:nvSpPr>
-          <p:cNvPr id="7" name="text-72">
+          <p:cNvPr id="7" name="text-75">
             <a:extLst xmlns:a="http://schemas.openxmlformats.org/drawingml/2006/main">
               <a:ext uri="{FF2B5EF4-FFF2-40B4-BE49-F238E27FC236}">
-                <a16:creationId xmlns:a16="http://schemas.microsoft.com/office/drawing/2014/main" id="{328B0225-DFFD-4F76-95C6-F97DBCF6BCE4}"/>
+                <a16:creationId xmlns:a16="http://schemas.microsoft.com/office/drawing/2014/main" id="{33329F97-5C69-45A7-A131-9BA003EBB4B7}"/>
               </a:ext>
             </a:extLst>
           </p:cNvPr>
@@ -9554,10 +9743,10 @@
       </p:sp>
       <p:sp>
         <p:nvSpPr>
-          <p:cNvPr id="8" name="text-73">
+          <p:cNvPr id="8" name="text-76">
             <a:extLst xmlns:a="http://schemas.openxmlformats.org/drawingml/2006/main">
               <a:ext uri="{FF2B5EF4-FFF2-40B4-BE49-F238E27FC236}">
-                <a16:creationId xmlns:a16="http://schemas.microsoft.com/office/drawing/2014/main" id="{1B5EAC3B-9F42-4C79-B64E-3D58280B3E3B}"/>
+                <a16:creationId xmlns:a16="http://schemas.microsoft.com/office/drawing/2014/main" id="{4F7EEBB6-504D-4F37-B531-A89F6834AE86}"/>
               </a:ext>
             </a:extLst>
           </p:cNvPr>
@@ -9611,10 +9800,10 @@
       </p:sp>
       <p:sp>
         <p:nvSpPr>
-          <p:cNvPr id="9" name="text-74">
+          <p:cNvPr id="9" name="text-77">
             <a:extLst xmlns:a="http://schemas.openxmlformats.org/drawingml/2006/main">
               <a:ext uri="{FF2B5EF4-FFF2-40B4-BE49-F238E27FC236}">
-                <a16:creationId xmlns:a16="http://schemas.microsoft.com/office/drawing/2014/main" id="{6902AECB-391F-465E-9334-2F2E0CEE997D}"/>
+                <a16:creationId xmlns:a16="http://schemas.microsoft.com/office/drawing/2014/main" id="{0A5FABDC-C454-4B56-B24D-50A2C1F8562A}"/>
               </a:ext>
             </a:extLst>
           </p:cNvPr>
@@ -9669,7 +9858,7 @@
     </p:spTree>
     <p:extLst>
       <p:ext uri="{BB962C8B-B14F-4D97-AF65-F5344CB8AC3E}">
-        <p14:creationId xmlns:p14="http://schemas.microsoft.com/office/powerpoint/2010/main" val="2009366579"/>
+        <p14:creationId xmlns:p14="http://schemas.microsoft.com/office/powerpoint/2010/main" val="1675159222"/>
       </p:ext>
     </p:extLst>
   </p:cSld>

</xml_diff>